<commit_message>
Update presentation with DR root cause fix, Google Slides compat, and stage detection
</commit_message>
<xml_diff>
--- a/docs/agent_cpu_evaluation.pptx
+++ b/docs/agent_cpu_evaluation.pptx
@@ -19,6 +19,7 @@
     <p:sldId id="267" r:id="rId18"/>
     <p:sldId id="268" r:id="rId19"/>
     <p:sldId id="269" r:id="rId20"/>
+    <p:sldId id="270" r:id="rId21"/>
   </p:sldIdLst>
   <p:sldSz cx="12191695" cy="6858000" type="screen4x3"/>
   <p:notesSz cx="6858000" cy="9144000"/>
@@ -118,338 +119,6 @@
     </a:lvl9pPr>
   </p:defaultTextStyle>
 </p:presentation>
-</file>
-
-<file path=ppt/charts/chart1.xml><?xml version="1.0" encoding="utf-8"?>
-<c:chartSpace xmlns:c="http://schemas.openxmlformats.org/drawingml/2006/chart" xmlns:a="http://schemas.openxmlformats.org/drawingml/2006/main" xmlns:r="http://schemas.openxmlformats.org/officeDocument/2006/relationships">
-  <c:date1904 val="0"/>
-  <c:chart>
-    <c:autoTitleDeleted val="0"/>
-    <c:plotArea>
-      <c:barChart>
-        <c:barDir val="col"/>
-        <c:grouping val="stacked"/>
-        <c:ser>
-          <c:idx val="0"/>
-          <c:order val="0"/>
-          <c:tx>
-            <c:strRef>
-              <c:f>Sheet1!$B$1</c:f>
-              <c:strCache>
-                <c:ptCount val="1"/>
-                <c:pt idx="0">
-                  <c:v>Retiring</c:v>
-                </c:pt>
-              </c:strCache>
-            </c:strRef>
-          </c:tx>
-          <c:spPr>
-            <a:solidFill>
-              <a:srgbClr val="2CA02C"/>
-            </a:solidFill>
-          </c:spPr>
-          <c:cat>
-            <c:strRef>
-              <c:f>Sheet1!$A$2:$A$6</c:f>
-              <c:strCache>
-                <c:ptCount val="5"/>
-                <c:pt idx="0">
-                  <c:v>LangChain</c:v>
-                </c:pt>
-                <c:pt idx="1">
-                  <c:v>LangGraph</c:v>
-                </c:pt>
-                <c:pt idx="2">
-                  <c:v>AutoGen</c:v>
-                </c:pt>
-                <c:pt idx="3">
-                  <c:v>Haystack</c:v>
-                </c:pt>
-                <c:pt idx="4">
-                  <c:v>SWE-Agent</c:v>
-                </c:pt>
-              </c:strCache>
-            </c:strRef>
-          </c:cat>
-          <c:val>
-            <c:numRef>
-              <c:f>Sheet1!$B$2:$B$6</c:f>
-              <c:numCache>
-                <c:formatCode>General</c:formatCode>
-                <c:ptCount val="5"/>
-                <c:pt idx="0">
-                  <c:v>19.016666666666666</c:v>
-                </c:pt>
-                <c:pt idx="1">
-                  <c:v>17.95</c:v>
-                </c:pt>
-                <c:pt idx="2">
-                  <c:v>19.466666666666665</c:v>
-                </c:pt>
-                <c:pt idx="3">
-                  <c:v>22.083333333333332</c:v>
-                </c:pt>
-                <c:pt idx="4">
-                  <c:v>19.916666666666668</c:v>
-                </c:pt>
-              </c:numCache>
-            </c:numRef>
-          </c:val>
-        </c:ser>
-        <c:ser>
-          <c:idx val="1"/>
-          <c:order val="1"/>
-          <c:tx>
-            <c:strRef>
-              <c:f>Sheet1!$C$1</c:f>
-              <c:strCache>
-                <c:ptCount val="1"/>
-                <c:pt idx="0">
-                  <c:v>Bad Speculation</c:v>
-                </c:pt>
-              </c:strCache>
-            </c:strRef>
-          </c:tx>
-          <c:spPr>
-            <a:solidFill>
-              <a:srgbClr val="FF7F0E"/>
-            </a:solidFill>
-          </c:spPr>
-          <c:cat>
-            <c:strRef>
-              <c:f>Sheet1!$A$2:$A$6</c:f>
-              <c:strCache>
-                <c:ptCount val="5"/>
-                <c:pt idx="0">
-                  <c:v>LangChain</c:v>
-                </c:pt>
-                <c:pt idx="1">
-                  <c:v>LangGraph</c:v>
-                </c:pt>
-                <c:pt idx="2">
-                  <c:v>AutoGen</c:v>
-                </c:pt>
-                <c:pt idx="3">
-                  <c:v>Haystack</c:v>
-                </c:pt>
-                <c:pt idx="4">
-                  <c:v>SWE-Agent</c:v>
-                </c:pt>
-              </c:strCache>
-            </c:strRef>
-          </c:cat>
-          <c:val>
-            <c:numRef>
-              <c:f>Sheet1!$C$2:$C$6</c:f>
-              <c:numCache>
-                <c:formatCode>General</c:formatCode>
-                <c:ptCount val="5"/>
-                <c:pt idx="0">
-                  <c:v>4.216666666666667</c:v>
-                </c:pt>
-                <c:pt idx="1">
-                  <c:v>4.066666666666666</c:v>
-                </c:pt>
-                <c:pt idx="2">
-                  <c:v>4.616666666666667</c:v>
-                </c:pt>
-                <c:pt idx="3">
-                  <c:v>4.8999999999999995</c:v>
-                </c:pt>
-                <c:pt idx="4">
-                  <c:v>4.533333333333333</c:v>
-                </c:pt>
-              </c:numCache>
-            </c:numRef>
-          </c:val>
-        </c:ser>
-        <c:ser>
-          <c:idx val="2"/>
-          <c:order val="2"/>
-          <c:tx>
-            <c:strRef>
-              <c:f>Sheet1!$D$1</c:f>
-              <c:strCache>
-                <c:ptCount val="1"/>
-                <c:pt idx="0">
-                  <c:v>Frontend Bound</c:v>
-                </c:pt>
-              </c:strCache>
-            </c:strRef>
-          </c:tx>
-          <c:spPr>
-            <a:solidFill>
-              <a:srgbClr val="1F77B4"/>
-            </a:solidFill>
-          </c:spPr>
-          <c:cat>
-            <c:strRef>
-              <c:f>Sheet1!$A$2:$A$6</c:f>
-              <c:strCache>
-                <c:ptCount val="5"/>
-                <c:pt idx="0">
-                  <c:v>LangChain</c:v>
-                </c:pt>
-                <c:pt idx="1">
-                  <c:v>LangGraph</c:v>
-                </c:pt>
-                <c:pt idx="2">
-                  <c:v>AutoGen</c:v>
-                </c:pt>
-                <c:pt idx="3">
-                  <c:v>Haystack</c:v>
-                </c:pt>
-                <c:pt idx="4">
-                  <c:v>SWE-Agent</c:v>
-                </c:pt>
-              </c:strCache>
-            </c:strRef>
-          </c:cat>
-          <c:val>
-            <c:numRef>
-              <c:f>Sheet1!$D$2:$D$6</c:f>
-              <c:numCache>
-                <c:formatCode>General</c:formatCode>
-                <c:ptCount val="5"/>
-                <c:pt idx="0">
-                  <c:v>26.55</c:v>
-                </c:pt>
-                <c:pt idx="1">
-                  <c:v>30.783333333333335</c:v>
-                </c:pt>
-                <c:pt idx="2">
-                  <c:v>32.233333333333334</c:v>
-                </c:pt>
-                <c:pt idx="3">
-                  <c:v>28.566666666666666</c:v>
-                </c:pt>
-                <c:pt idx="4">
-                  <c:v>26.683333333333334</c:v>
-                </c:pt>
-              </c:numCache>
-            </c:numRef>
-          </c:val>
-        </c:ser>
-        <c:ser>
-          <c:idx val="3"/>
-          <c:order val="3"/>
-          <c:tx>
-            <c:strRef>
-              <c:f>Sheet1!$E$1</c:f>
-              <c:strCache>
-                <c:ptCount val="1"/>
-                <c:pt idx="0">
-                  <c:v>Backend Bound</c:v>
-                </c:pt>
-              </c:strCache>
-            </c:strRef>
-          </c:tx>
-          <c:spPr>
-            <a:solidFill>
-              <a:srgbClr val="D62728"/>
-            </a:solidFill>
-          </c:spPr>
-          <c:cat>
-            <c:strRef>
-              <c:f>Sheet1!$A$2:$A$6</c:f>
-              <c:strCache>
-                <c:ptCount val="5"/>
-                <c:pt idx="0">
-                  <c:v>LangChain</c:v>
-                </c:pt>
-                <c:pt idx="1">
-                  <c:v>LangGraph</c:v>
-                </c:pt>
-                <c:pt idx="2">
-                  <c:v>AutoGen</c:v>
-                </c:pt>
-                <c:pt idx="3">
-                  <c:v>Haystack</c:v>
-                </c:pt>
-                <c:pt idx="4">
-                  <c:v>SWE-Agent</c:v>
-                </c:pt>
-              </c:strCache>
-            </c:strRef>
-          </c:cat>
-          <c:val>
-            <c:numRef>
-              <c:f>Sheet1!$E$2:$E$6</c:f>
-              <c:numCache>
-                <c:formatCode>General</c:formatCode>
-                <c:ptCount val="5"/>
-                <c:pt idx="0">
-                  <c:v>50.18333333333334</c:v>
-                </c:pt>
-                <c:pt idx="1">
-                  <c:v>47.21666666666667</c:v>
-                </c:pt>
-                <c:pt idx="2">
-                  <c:v>43.68333333333334</c:v>
-                </c:pt>
-                <c:pt idx="3">
-                  <c:v>44.46666666666667</c:v>
-                </c:pt>
-                <c:pt idx="4">
-                  <c:v>48.86666666666667</c:v>
-                </c:pt>
-              </c:numCache>
-            </c:numRef>
-          </c:val>
-        </c:ser>
-        <c:overlap val="100"/>
-        <c:axId val="-2068027336"/>
-        <c:axId val="-2113994440"/>
-      </c:barChart>
-      <c:catAx>
-        <c:axId val="-2068027336"/>
-        <c:scaling>
-          <c:orientation val="minMax"/>
-        </c:scaling>
-        <c:delete val="0"/>
-        <c:axPos val="b"/>
-        <c:majorTickMark val="out"/>
-        <c:minorTickMark val="none"/>
-        <c:tickLblPos val="nextTo"/>
-        <c:crossAx val="-2113994440"/>
-        <c:crosses val="autoZero"/>
-        <c:auto val="1"/>
-        <c:lblAlgn val="ctr"/>
-        <c:lblOffset val="100"/>
-        <c:noMultiLvlLbl val="0"/>
-      </c:catAx>
-      <c:valAx>
-        <c:axId val="-2113994440"/>
-        <c:scaling/>
-        <c:delete val="0"/>
-        <c:axPos val="l"/>
-        <c:majorGridlines/>
-        <c:majorTickMark val="out"/>
-        <c:minorTickMark val="none"/>
-        <c:tickLblPos val="nextTo"/>
-        <c:crossAx val="-2068027336"/>
-        <c:crosses val="autoZero"/>
-      </c:valAx>
-    </c:plotArea>
-    <c:legend>
-      <c:overlay val="0"/>
-    </c:legend>
-    <c:dispBlanksAs val="gap"/>
-  </c:chart>
-  <c:txPr>
-    <a:bodyPr/>
-    <a:lstStyle/>
-    <a:p>
-      <a:pPr>
-        <a:defRPr sz="1800"/>
-      </a:pPr>
-      <a:endParaRPr lang="en-US"/>
-    </a:p>
-  </c:txPr>
-  <c:externalData r:id="rId1">
-    <c:autoUpdate val="0"/>
-  </c:externalData>
-</c:chartSpace>
 </file>
 
 <file path=ppt/slideLayouts/slideLayout1.xml><?xml version="1.0" encoding="utf-8"?>
@@ -3665,7 +3334,7 @@
               </a:defRPr>
             </a:pPr>
             <a:r>
-              <a:t>Problem: SIGSEGV crash in d_r_strcmp during multi-threaded Python workloads</a:t>
+              <a:t>Two problems with DynamoRIO on multi-threaded Python workloads</a:t>
             </a:r>
           </a:p>
         </p:txBody>
@@ -3703,7 +3372,7 @@
               </a:defRPr>
             </a:pPr>
             <a:r>
-              <a:t>Root Cause: Race condition in module_list_remove() (core/module_list.c:290-342)</a:t>
+              <a:t>Root Cause 1: SIGSEGV crash — race in module_list_remove() (core/module_list.c)</a:t>
             </a:r>
           </a:p>
           <a:p>
@@ -3718,7 +3387,7 @@
               </a:defRPr>
             </a:pPr>
             <a:r>
-              <a:t>Thread A: releases write lock (line 322) for client callback, module still in vmvector</a:t>
+              <a:t>module_list_remove() released write lock for client callback, module still in vmvector</a:t>
             </a:r>
           </a:p>
           <a:p>
@@ -3733,7 +3402,7 @@
               </a:defRPr>
             </a:pPr>
             <a:r>
-              <a:t>Thread B: gets module name pointer via vmvector lookup, releases read lock</a:t>
+              <a:t>Another thread gets module name pointer via vmvector_lookup during this window</a:t>
             </a:r>
           </a:p>
           <a:p>
@@ -3748,7 +3417,34 @@
               </a:defRPr>
             </a:pPr>
             <a:r>
-              <a:t>Thread A: reacquires lock, frees module data (line 338) — Thread B's pointer is now stale</a:t>
+              <a:t>First thread re-acquires lock, frees module data → second thread's pointer is stale → SIGSEGV</a:t>
+            </a:r>
+          </a:p>
+          <a:p>
+            <a:pPr>
+              <a:spcAft>
+                <a:spcPts val="300"/>
+              </a:spcAft>
+              <a:defRPr sz="1300">
+                <a:solidFill>
+                  <a:srgbClr val="2D2D2D"/>
+                </a:solidFill>
+              </a:defRPr>
+            </a:pPr>
+          </a:p>
+          <a:p>
+            <a:pPr>
+              <a:spcAft>
+                <a:spcPts val="300"/>
+              </a:spcAft>
+              <a:defRPr sz="1300">
+                <a:solidFill>
+                  <a:srgbClr val="2D2D2D"/>
+                </a:solidFill>
+              </a:defRPr>
+            </a:pPr>
+            <a:r>
+              <a:t>Root Cause 2: libfpg.so not loading — DR config cross-contamination on shared NFS</a:t>
             </a:r>
           </a:p>
           <a:p>
@@ -3763,7 +3459,37 @@
               </a:defRPr>
             </a:pPr>
             <a:r>
-              <a:t>Thread B: calls d_r_strcmp with freed pointer → SIGSEGV or garbage data</a:t>
+              <a:t>DR caches per-process configs in ~/.dynamorio/ keyed by binary+PID</a:t>
+            </a:r>
+          </a:p>
+          <a:p>
+            <a:pPr lvl="1">
+              <a:spcAft>
+                <a:spcPts val="300"/>
+              </a:spcAft>
+              <a:defRPr sz="1300">
+                <a:solidFill>
+                  <a:srgbClr val="2D2D2D"/>
+                </a:solidFill>
+              </a:defRPr>
+            </a:pPr>
+            <a:r>
+              <a:t>Concurrent slurm jobs on same NFS home pick up each other's config files</a:t>
+            </a:r>
+          </a:p>
+          <a:p>
+            <a:pPr lvl="1">
+              <a:spcAft>
+                <a:spcPts val="300"/>
+              </a:spcAft>
+              <a:defRPr sz="1300">
+                <a:solidFill>
+                  <a:srgbClr val="2D2D2D"/>
+                </a:solidFill>
+              </a:defRPr>
+            </a:pPr>
+            <a:r>
+              <a:t>Wrong config → libfpg.so client not loaded → empty fingerprint output</a:t>
             </a:r>
           </a:p>
           <a:p>
@@ -3790,7 +3516,7 @@
               </a:defRPr>
             </a:pPr>
             <a:r>
-              <a:t>Fix 1: d_r_strcmp safe_read guard (core/string.c + core/drlibc/drlibc.c)</a:t>
+              <a:t>Fix 1 (for RC1): Root cause fix in module_list_remove() (core/module_list.c)</a:t>
             </a:r>
           </a:p>
           <a:p>
@@ -3805,7 +3531,7 @@
               </a:defRPr>
             </a:pPr>
             <a:r>
-              <a:t>Added d_r_safe_read() probe before dereferencing; returns 0 (equal) on bad pointers</a:t>
+              <a:t>Move module_area_delete() + vmvector removal before releasing write lock</a:t>
             </a:r>
           </a:p>
           <a:p>
@@ -3820,7 +3546,22 @@
               </a:defRPr>
             </a:pPr>
             <a:r>
-              <a:t>Returning 0 breaks callers out of open-addressing hash table loops</a:t>
+              <a:t>Client callback only uses client_data (a copy), does not need original module_area_t</a:t>
+            </a:r>
+          </a:p>
+          <a:p>
+            <a:pPr lvl="1">
+              <a:spcAft>
+                <a:spcPts val="300"/>
+              </a:spcAft>
+              <a:defRPr sz="1300">
+                <a:solidFill>
+                  <a:srgbClr val="2D2D2D"/>
+                </a:solidFill>
+              </a:defRPr>
+            </a:pPr>
+            <a:r>
+              <a:t>Eliminates the race window entirely — no thread can get a stale pointer</a:t>
             </a:r>
           </a:p>
           <a:p>
@@ -3847,7 +3588,7 @@
               </a:defRPr>
             </a:pPr>
             <a:r>
-              <a:t>Fix 2: strhash_key_cmp guard (core/hashtable.c)</a:t>
+              <a:t>Fix 2 (for RC1): strhash_key_cmp safe_read guard (core/hashtable.c)</a:t>
             </a:r>
           </a:p>
           <a:p>
@@ -3862,7 +3603,34 @@
               </a:defRPr>
             </a:pPr>
             <a:r>
-              <a:t>Added safe_read in hash table key comparator; returns true (match) on bad pointers</a:t>
+              <a:t>Defense-in-depth: safe_read check on hash table key pointers before strcmp</a:t>
+            </a:r>
+          </a:p>
+          <a:p>
+            <a:pPr>
+              <a:spcAft>
+                <a:spcPts val="300"/>
+              </a:spcAft>
+              <a:defRPr sz="1300">
+                <a:solidFill>
+                  <a:srgbClr val="2D2D2D"/>
+                </a:solidFill>
+              </a:defRPr>
+            </a:pPr>
+          </a:p>
+          <a:p>
+            <a:pPr>
+              <a:spcAft>
+                <a:spcPts val="300"/>
+              </a:spcAft>
+              <a:defRPr sz="1300">
+                <a:solidFill>
+                  <a:srgbClr val="2D2D2D"/>
+                </a:solidFill>
+              </a:defRPr>
+            </a:pPr>
+            <a:r>
+              <a:t>Fix 3 (for RC2): Per-job HOME override (scarab-infra, run_simpoint_trace.py)</a:t>
             </a:r>
           </a:p>
           <a:p>
@@ -3877,79 +3645,7 @@
               </a:defRPr>
             </a:pPr>
             <a:r>
-              <a:t>Prevents infinite loops in open-addressing lookup when keys are stale</a:t>
-            </a:r>
-          </a:p>
-          <a:p>
-            <a:pPr>
-              <a:spcAft>
-                <a:spcPts val="300"/>
-              </a:spcAft>
-              <a:defRPr sz="1300">
-                <a:solidFill>
-                  <a:srgbClr val="2D2D2D"/>
-                </a:solidFill>
-              </a:defRPr>
-            </a:pPr>
-          </a:p>
-          <a:p>
-            <a:pPr>
-              <a:spcAft>
-                <a:spcPts val="300"/>
-              </a:spcAft>
-              <a:defRPr sz="1300">
-                <a:solidFill>
-                  <a:srgbClr val="2D2D2D"/>
-                </a:solidFill>
-              </a:defRPr>
-            </a:pPr>
-            <a:r>
-              <a:t>Fix 3: DYNAMORIO_CONFIGDIR isolation (scarab-infra side)</a:t>
-            </a:r>
-          </a:p>
-          <a:p>
-            <a:pPr lvl="1">
-              <a:spcAft>
-                <a:spcPts val="300"/>
-              </a:spcAft>
-              <a:defRPr sz="1300">
-                <a:solidFill>
-                  <a:srgbClr val="2D2D2D"/>
-                </a:solidFill>
-              </a:defRPr>
-            </a:pPr>
-            <a:r>
-              <a:t>DR caches per-process configs in ~/.dynamorio/ keyed by binary+PID</a:t>
-            </a:r>
-          </a:p>
-          <a:p>
-            <a:pPr lvl="1">
-              <a:spcAft>
-                <a:spcPts val="300"/>
-              </a:spcAft>
-              <a:defRPr sz="1300">
-                <a:solidFill>
-                  <a:srgbClr val="2D2D2D"/>
-                </a:solidFill>
-              </a:defRPr>
-            </a:pPr>
-            <a:r>
-              <a:t>Concurrent jobs on same NFS home caused config cross-contamination</a:t>
-            </a:r>
-          </a:p>
-          <a:p>
-            <a:pPr lvl="1">
-              <a:spcAft>
-                <a:spcPts val="300"/>
-              </a:spcAft>
-              <a:defRPr sz="1300">
-                <a:solidFill>
-                  <a:srgbClr val="2D2D2D"/>
-                </a:solidFill>
-              </a:defRPr>
-            </a:pPr>
-            <a:r>
-              <a:t>Solution: per-workload config directory via DYNAMORIO_CONFIGDIR env var</a:t>
+              <a:t>HOME={workload_dir} on drrun commands — isolates ~/.dynamorio/ per job</a:t>
             </a:r>
           </a:p>
         </p:txBody>
@@ -4312,7 +4008,7 @@
               </a:defRPr>
             </a:pPr>
             <a:r>
-              <a:t>Scarab is single-core: simulating main thread is representative</a:t>
+              <a:t>Simulating the dominant thread on a single core is representative</a:t>
             </a:r>
           </a:p>
         </p:txBody>
@@ -4393,7 +4089,7 @@
         <a:graphic>
           <a:graphicData uri="http://schemas.openxmlformats.org/drawingml/2006/table">
             <a:tbl>
-              <a:tblPr firstRow="1" bandRow="1">
+              <a:tblPr>
                 <a:tableStyleId>{5C22544A-7EE6-4342-B048-85BDC9FD1C3A}</a:tableStyleId>
               </a:tblPr>
               <a:tblGrid>
@@ -5205,7 +4901,7 @@
                         </a:defRPr>
                       </a:pPr>
                       <a:r>
-                        <a:t>Deployed</a:t>
+                        <a:t>Fixed</a:t>
                       </a:r>
                     </a:p>
                   </a:txBody>
@@ -5250,7 +4946,7 @@
                         </a:defRPr>
                       </a:pPr>
                       <a:r>
-                        <a:t>3 fixes on 5surim/dynamorio:release_10.0.0</a:t>
+                        <a:t>Root cause fix in module_list_remove()</a:t>
                       </a:r>
                     </a:p>
                     <a:p>
@@ -5262,7 +4958,7 @@
                         </a:defRPr>
                       </a:pPr>
                       <a:r>
-                        <a:t>Workaround for module_list_remove race</a:t>
+                        <a:t>+ strhash_key_cmp guard + HOME isolation</a:t>
                       </a:r>
                     </a:p>
                   </a:txBody>
@@ -5492,7 +5188,7 @@
               </a:defRPr>
             </a:pPr>
             <a:r>
-              <a:t>Next Steps</a:t>
+              <a:t>Next Steps (1/2): Trace Collection &amp; Analysis</a:t>
             </a:r>
           </a:p>
         </p:txBody>
@@ -5716,7 +5412,7 @@
               </a:defRPr>
             </a:pPr>
             <a:r>
-              <a:t>4. Architecture sensitivity studies</a:t>
+              <a:t>4. Control flow graph (CFG) analysis</a:t>
             </a:r>
           </a:p>
           <a:p>
@@ -5731,7 +5427,7 @@
               </a:defRPr>
             </a:pPr>
             <a:r>
-              <a:t>Sweep cache sizes, branch predictor configs, prefetcher policies</a:t>
+              <a:t>Extract CFGs from traces: basic block size distribution, branch type breakdown</a:t>
             </a:r>
           </a:p>
           <a:p>
@@ -5746,11 +5442,11 @@
               </a:defRPr>
             </a:pPr>
             <a:r>
-              <a:t>Identify which microarchitectural knobs matter most for agent workloads</a:t>
-            </a:r>
-          </a:p>
-          <a:p>
-            <a:pPr>
+              <a:t>Compare loop depth, fan-out, indirect branch density across workloads</a:t>
+            </a:r>
+          </a:p>
+          <a:p>
+            <a:pPr lvl="1">
               <a:spcAft>
                 <a:spcPts val="300"/>
               </a:spcAft>
@@ -5760,50 +5456,8 @@
                 </a:solidFill>
               </a:defRPr>
             </a:pPr>
-          </a:p>
-          <a:p>
-            <a:pPr>
-              <a:spcAft>
-                <a:spcPts val="300"/>
-              </a:spcAft>
-              <a:defRPr sz="1500">
-                <a:solidFill>
-                  <a:srgbClr val="2D2D2D"/>
-                </a:solidFill>
-              </a:defRPr>
-            </a:pPr>
-            <a:r>
-              <a:t>5. Upstream DynamoRIO fix</a:t>
-            </a:r>
-          </a:p>
-          <a:p>
-            <a:pPr lvl="1">
-              <a:spcAft>
-                <a:spcPts val="300"/>
-              </a:spcAft>
-              <a:defRPr sz="1500">
-                <a:solidFill>
-                  <a:srgbClr val="2D2D2D"/>
-                </a:solidFill>
-              </a:defRPr>
-            </a:pPr>
-            <a:r>
-              <a:t>Proper fix: remove module from vmvector before releasing write lock in module_list_remove()</a:t>
-            </a:r>
-          </a:p>
-          <a:p>
-            <a:pPr lvl="1">
-              <a:spcAft>
-                <a:spcPts val="300"/>
-              </a:spcAft>
-              <a:defRPr sz="1500">
-                <a:solidFill>
-                  <a:srgbClr val="2D2D2D"/>
-                </a:solidFill>
-              </a:defRPr>
-            </a:pPr>
-            <a:r>
-              <a:t>Submit PR to DynamoRIO upstream repo</a:t>
+            <a:r>
+              <a:t>Hot code footprint: what fraction of unique PCs covers 90%/99% of execution?</a:t>
             </a:r>
           </a:p>
         </p:txBody>
@@ -5857,6 +5511,351 @@
           <a:lstStyle/>
           <a:p>
             <a:pPr>
+              <a:defRPr sz="3000" b="1">
+                <a:solidFill>
+                  <a:srgbClr val="2B579A"/>
+                </a:solidFill>
+              </a:defRPr>
+            </a:pPr>
+            <a:r>
+              <a:t>Next Steps (2/2): Architecture Sensitivity Studies</a:t>
+            </a:r>
+          </a:p>
+        </p:txBody>
+      </p:sp>
+      <p:sp>
+        <p:nvSpPr>
+          <p:cNvPr id="3" name="TextBox 2"/>
+          <p:cNvSpPr txBox="1"/>
+          <p:nvPr/>
+        </p:nvSpPr>
+        <p:spPr>
+          <a:xfrm>
+            <a:off x="640080" y="1097280"/>
+            <a:ext cx="10972800" cy="5029200"/>
+          </a:xfrm>
+          <a:prstGeom prst="rect">
+            <a:avLst/>
+          </a:prstGeom>
+          <a:noFill/>
+        </p:spPr>
+        <p:txBody>
+          <a:bodyPr wrap="square">
+            <a:spAutoFit/>
+          </a:bodyPr>
+          <a:lstStyle/>
+          <a:p>
+            <a:pPr>
+              <a:spcAft>
+                <a:spcPts val="300"/>
+              </a:spcAft>
+              <a:defRPr sz="1500">
+                <a:solidFill>
+                  <a:srgbClr val="2D2D2D"/>
+                </a:solidFill>
+              </a:defRPr>
+            </a:pPr>
+            <a:r>
+              <a:t>5. Frontend-bound studies</a:t>
+            </a:r>
+          </a:p>
+          <a:p>
+            <a:pPr lvl="1">
+              <a:spcAft>
+                <a:spcPts val="300"/>
+              </a:spcAft>
+              <a:defRPr sz="1500">
+                <a:solidFill>
+                  <a:srgbClr val="2D2D2D"/>
+                </a:solidFill>
+              </a:defRPr>
+            </a:pPr>
+            <a:r>
+              <a:t>I-cache size sweep (32/64/128KB) — Python's large code footprint likely causes high i-miss</a:t>
+            </a:r>
+          </a:p>
+          <a:p>
+            <a:pPr lvl="1">
+              <a:spcAft>
+                <a:spcPts val="300"/>
+              </a:spcAft>
+              <a:defRPr sz="1500">
+                <a:solidFill>
+                  <a:srgbClr val="2D2D2D"/>
+                </a:solidFill>
+              </a:defRPr>
+            </a:pPr>
+            <a:r>
+              <a:t>BTB size sensitivity — many indirect branch targets from polymorphic dispatch</a:t>
+            </a:r>
+          </a:p>
+          <a:p>
+            <a:pPr lvl="1">
+              <a:spcAft>
+                <a:spcPts val="300"/>
+              </a:spcAft>
+              <a:defRPr sz="1500">
+                <a:solidFill>
+                  <a:srgbClr val="2D2D2D"/>
+                </a:solidFill>
+              </a:defRPr>
+            </a:pPr>
+            <a:r>
+              <a:t>Fetch/decode width sensitivity — wider frontend vs capacity-bound?</a:t>
+            </a:r>
+          </a:p>
+          <a:p>
+            <a:pPr>
+              <a:spcAft>
+                <a:spcPts val="300"/>
+              </a:spcAft>
+              <a:defRPr sz="1500">
+                <a:solidFill>
+                  <a:srgbClr val="2D2D2D"/>
+                </a:solidFill>
+              </a:defRPr>
+            </a:pPr>
+          </a:p>
+          <a:p>
+            <a:pPr>
+              <a:spcAft>
+                <a:spcPts val="300"/>
+              </a:spcAft>
+              <a:defRPr sz="1500">
+                <a:solidFill>
+                  <a:srgbClr val="2D2D2D"/>
+                </a:solidFill>
+              </a:defRPr>
+            </a:pPr>
+            <a:r>
+              <a:t>6. Backend-bound studies</a:t>
+            </a:r>
+          </a:p>
+          <a:p>
+            <a:pPr lvl="1">
+              <a:spcAft>
+                <a:spcPts val="300"/>
+              </a:spcAft>
+              <a:defRPr sz="1500">
+                <a:solidFill>
+                  <a:srgbClr val="2D2D2D"/>
+                </a:solidFill>
+              </a:defRPr>
+            </a:pPr>
+            <a:r>
+              <a:t>D-cache hierarchy sweep: L1D (32/48/64KB), L2 (256/512KB/1MB), LLC (2/4/8MB)</a:t>
+            </a:r>
+          </a:p>
+          <a:p>
+            <a:pPr lvl="1">
+              <a:spcAft>
+                <a:spcPts val="300"/>
+              </a:spcAft>
+              <a:defRPr sz="1500">
+                <a:solidFill>
+                  <a:srgbClr val="2D2D2D"/>
+                </a:solidFill>
+              </a:defRPr>
+            </a:pPr>
+            <a:r>
+              <a:t>Reuse distance analysis — quantify temporal locality in dict/JSON/hash table accesses</a:t>
+            </a:r>
+          </a:p>
+          <a:p>
+            <a:pPr lvl="1">
+              <a:spcAft>
+                <a:spcPts val="300"/>
+              </a:spcAft>
+              <a:defRPr sz="1500">
+                <a:solidFill>
+                  <a:srgbClr val="2D2D2D"/>
+                </a:solidFill>
+              </a:defRPr>
+            </a:pPr>
+            <a:r>
+              <a:t>ROB size sensitivity (256/384/512) — larger ROB to extract MLP and hide cache misses</a:t>
+            </a:r>
+          </a:p>
+          <a:p>
+            <a:pPr lvl="1">
+              <a:spcAft>
+                <a:spcPts val="300"/>
+              </a:spcAft>
+              <a:defRPr sz="1500">
+                <a:solidFill>
+                  <a:srgbClr val="2D2D2D"/>
+                </a:solidFill>
+              </a:defRPr>
+            </a:pPr>
+            <a:r>
+              <a:t>Prefetcher effectiveness — stride vs complex; irregular access patterns may defeat stride</a:t>
+            </a:r>
+          </a:p>
+          <a:p>
+            <a:pPr>
+              <a:spcAft>
+                <a:spcPts val="300"/>
+              </a:spcAft>
+              <a:defRPr sz="1500">
+                <a:solidFill>
+                  <a:srgbClr val="2D2D2D"/>
+                </a:solidFill>
+              </a:defRPr>
+            </a:pPr>
+          </a:p>
+          <a:p>
+            <a:pPr>
+              <a:spcAft>
+                <a:spcPts val="300"/>
+              </a:spcAft>
+              <a:defRPr sz="1500">
+                <a:solidFill>
+                  <a:srgbClr val="2D2D2D"/>
+                </a:solidFill>
+              </a:defRPr>
+            </a:pPr>
+            <a:r>
+              <a:t>7. Cross-cutting studies</a:t>
+            </a:r>
+          </a:p>
+          <a:p>
+            <a:pPr lvl="1">
+              <a:spcAft>
+                <a:spcPts val="300"/>
+              </a:spcAft>
+              <a:defRPr sz="1500">
+                <a:solidFill>
+                  <a:srgbClr val="2D2D2D"/>
+                </a:solidFill>
+              </a:defRPr>
+            </a:pPr>
+            <a:r>
+              <a:t>Core width sweep (4/6/8-wide) — are agent workloads ILP-limited?</a:t>
+            </a:r>
+          </a:p>
+          <a:p>
+            <a:pPr lvl="1">
+              <a:spcAft>
+                <a:spcPts val="300"/>
+              </a:spcAft>
+              <a:defRPr sz="1500">
+                <a:solidFill>
+                  <a:srgbClr val="2D2D2D"/>
+                </a:solidFill>
+              </a:defRPr>
+            </a:pPr>
+            <a:r>
+              <a:t>Branch predictor config sweep — TAGE history length, indirect predictor sizing</a:t>
+            </a:r>
+          </a:p>
+          <a:p>
+            <a:pPr lvl="1">
+              <a:spcAft>
+                <a:spcPts val="300"/>
+              </a:spcAft>
+              <a:defRPr sz="1500">
+                <a:solidFill>
+                  <a:srgbClr val="2D2D2D"/>
+                </a:solidFill>
+              </a:defRPr>
+            </a:pPr>
+            <a:r>
+              <a:t>Haystack (FP/SIMD) vs framework (branchy/string) — quantify architectural divergence</a:t>
+            </a:r>
+          </a:p>
+          <a:p>
+            <a:pPr>
+              <a:spcAft>
+                <a:spcPts val="300"/>
+              </a:spcAft>
+              <a:defRPr sz="1500">
+                <a:solidFill>
+                  <a:srgbClr val="2D2D2D"/>
+                </a:solidFill>
+              </a:defRPr>
+            </a:pPr>
+          </a:p>
+          <a:p>
+            <a:pPr>
+              <a:spcAft>
+                <a:spcPts val="300"/>
+              </a:spcAft>
+              <a:defRPr sz="1500">
+                <a:solidFill>
+                  <a:srgbClr val="2D2D2D"/>
+                </a:solidFill>
+              </a:defRPr>
+            </a:pPr>
+            <a:r>
+              <a:t>8. Upstream DynamoRIO fix</a:t>
+            </a:r>
+          </a:p>
+          <a:p>
+            <a:pPr lvl="1">
+              <a:spcAft>
+                <a:spcPts val="300"/>
+              </a:spcAft>
+              <a:defRPr sz="1500">
+                <a:solidFill>
+                  <a:srgbClr val="2D2D2D"/>
+                </a:solidFill>
+              </a:defRPr>
+            </a:pPr>
+            <a:r>
+              <a:t>Submit PR with module_list_remove() race fix to DynamoRIO upstream</a:t>
+            </a:r>
+          </a:p>
+        </p:txBody>
+      </p:sp>
+    </p:spTree>
+  </p:cSld>
+  <p:clrMapOvr>
+    <a:masterClrMapping/>
+  </p:clrMapOvr>
+</p:sld>
+</file>
+
+<file path=ppt/slides/slide15.xml><?xml version="1.0" encoding="utf-8"?>
+<p:sld xmlns:a="http://schemas.openxmlformats.org/drawingml/2006/main" xmlns:p="http://schemas.openxmlformats.org/presentationml/2006/main" xmlns:r="http://schemas.openxmlformats.org/officeDocument/2006/relationships">
+  <p:cSld>
+    <p:bg>
+      <p:bgPr>
+        <a:solidFill>
+          <a:srgbClr val="FFFFFF"/>
+        </a:solidFill>
+        <a:effectLst/>
+      </p:bgPr>
+    </p:bg>
+    <p:spTree>
+      <p:nvGrpSpPr>
+        <p:cNvPr id="1" name=""/>
+        <p:cNvGrpSpPr/>
+        <p:nvPr/>
+      </p:nvGrpSpPr>
+      <p:grpSpPr/>
+      <p:sp>
+        <p:nvSpPr>
+          <p:cNvPr id="2" name="TextBox 1"/>
+          <p:cNvSpPr txBox="1"/>
+          <p:nvPr/>
+        </p:nvSpPr>
+        <p:spPr>
+          <a:xfrm>
+            <a:off x="640080" y="274320"/>
+            <a:ext cx="10972800" cy="731520"/>
+          </a:xfrm>
+          <a:prstGeom prst="rect">
+            <a:avLst/>
+          </a:prstGeom>
+          <a:noFill/>
+        </p:spPr>
+        <p:txBody>
+          <a:bodyPr wrap="square">
+            <a:spAutoFit/>
+          </a:bodyPr>
+          <a:lstStyle/>
+          <a:p>
+            <a:pPr>
               <a:defRPr sz="2800" b="1">
                 <a:solidFill>
                   <a:srgbClr val="2B579A"/>
@@ -6433,7 +6432,7 @@
         <a:graphic>
           <a:graphicData uri="http://schemas.openxmlformats.org/drawingml/2006/table">
             <a:tbl>
-              <a:tblPr firstRow="1" bandRow="1">
+              <a:tblPr>
                 <a:tableStyleId>{5C22544A-7EE6-4342-B048-85BDC9FD1C3A}</a:tableStyleId>
               </a:tblPr>
               <a:tblGrid>
@@ -9094,7 +9093,7 @@
         <a:graphic>
           <a:graphicData uri="http://schemas.openxmlformats.org/drawingml/2006/table">
             <a:tbl>
-              <a:tblPr firstRow="1" bandRow="1">
+              <a:tblPr>
                 <a:tableStyleId>{5C22544A-7EE6-4342-B048-85BDC9FD1C3A}</a:tableStyleId>
               </a:tblPr>
               <a:tblGrid>
@@ -11207,24 +11206,2005 @@
           </a:p>
         </p:txBody>
       </p:sp>
-      <p:graphicFrame>
-        <p:nvGraphicFramePr>
-          <p:cNvPr id="3" name="Chart 2"/>
-          <p:cNvGraphicFramePr>
-            <a:graphicFrameLocks noGrp="1"/>
-          </p:cNvGraphicFramePr>
+      <p:sp>
+        <p:nvSpPr>
+          <p:cNvPr id="3" name="TextBox 2"/>
+          <p:cNvSpPr txBox="1"/>
           <p:nvPr/>
-        </p:nvGraphicFramePr>
-        <p:xfrm>
-          <a:off x="1371600" y="1188720"/>
-          <a:ext cx="9144000" cy="5029200"/>
-        </p:xfrm>
-        <a:graphic>
-          <a:graphicData uri="http://schemas.openxmlformats.org/drawingml/2006/chart">
-            <c:chart xmlns:c="http://schemas.openxmlformats.org/drawingml/2006/chart" r:id="rId2"/>
-          </a:graphicData>
-        </a:graphic>
-      </p:graphicFrame>
+        </p:nvSpPr>
+        <p:spPr>
+          <a:xfrm>
+            <a:off x="1097280" y="5397500"/>
+            <a:ext cx="640080" cy="274320"/>
+          </a:xfrm>
+          <a:prstGeom prst="rect">
+            <a:avLst/>
+          </a:prstGeom>
+          <a:noFill/>
+        </p:spPr>
+        <p:txBody>
+          <a:bodyPr wrap="square">
+            <a:spAutoFit/>
+          </a:bodyPr>
+          <a:lstStyle/>
+          <a:p>
+            <a:pPr>
+              <a:spcAft>
+                <a:spcPts val="400"/>
+              </a:spcAft>
+              <a:defRPr sz="1000">
+                <a:solidFill>
+                  <a:srgbClr val="7F7F7F"/>
+                </a:solidFill>
+              </a:defRPr>
+            </a:pPr>
+            <a:r>
+              <a:t>0%</a:t>
+            </a:r>
+          </a:p>
+        </p:txBody>
+      </p:sp>
+      <p:sp>
+        <p:nvSpPr>
+          <p:cNvPr id="4" name="Rectangle 3"/>
+          <p:cNvSpPr/>
+          <p:nvPr/>
+        </p:nvSpPr>
+        <p:spPr>
+          <a:xfrm>
+            <a:off x="1828800" y="5486400"/>
+            <a:ext cx="8686800" cy="6350"/>
+          </a:xfrm>
+          <a:prstGeom prst="rect">
+            <a:avLst/>
+          </a:prstGeom>
+          <a:solidFill>
+            <a:srgbClr val="F0F0F0"/>
+          </a:solidFill>
+          <a:ln>
+            <a:noFill/>
+          </a:ln>
+        </p:spPr>
+        <p:style>
+          <a:lnRef idx="1">
+            <a:schemeClr val="accent1"/>
+          </a:lnRef>
+          <a:fillRef idx="3">
+            <a:schemeClr val="accent1"/>
+          </a:fillRef>
+          <a:effectRef idx="2">
+            <a:schemeClr val="accent1"/>
+          </a:effectRef>
+          <a:fontRef idx="minor">
+            <a:schemeClr val="lt1"/>
+          </a:fontRef>
+        </p:style>
+        <p:txBody>
+          <a:bodyPr rtlCol="0" anchor="ctr"/>
+          <a:lstStyle/>
+          <a:p>
+            <a:pPr algn="ctr"/>
+          </a:p>
+        </p:txBody>
+      </p:sp>
+      <p:sp>
+        <p:nvSpPr>
+          <p:cNvPr id="5" name="TextBox 4"/>
+          <p:cNvSpPr txBox="1"/>
+          <p:nvPr/>
+        </p:nvSpPr>
+        <p:spPr>
+          <a:xfrm>
+            <a:off x="1097280" y="4368800"/>
+            <a:ext cx="640080" cy="274320"/>
+          </a:xfrm>
+          <a:prstGeom prst="rect">
+            <a:avLst/>
+          </a:prstGeom>
+          <a:noFill/>
+        </p:spPr>
+        <p:txBody>
+          <a:bodyPr wrap="square">
+            <a:spAutoFit/>
+          </a:bodyPr>
+          <a:lstStyle/>
+          <a:p>
+            <a:pPr>
+              <a:spcAft>
+                <a:spcPts val="400"/>
+              </a:spcAft>
+              <a:defRPr sz="1000">
+                <a:solidFill>
+                  <a:srgbClr val="7F7F7F"/>
+                </a:solidFill>
+              </a:defRPr>
+            </a:pPr>
+            <a:r>
+              <a:t>25%</a:t>
+            </a:r>
+          </a:p>
+        </p:txBody>
+      </p:sp>
+      <p:sp>
+        <p:nvSpPr>
+          <p:cNvPr id="6" name="Rectangle 5"/>
+          <p:cNvSpPr/>
+          <p:nvPr/>
+        </p:nvSpPr>
+        <p:spPr>
+          <a:xfrm>
+            <a:off x="1828800" y="4457700"/>
+            <a:ext cx="8686800" cy="6350"/>
+          </a:xfrm>
+          <a:prstGeom prst="rect">
+            <a:avLst/>
+          </a:prstGeom>
+          <a:solidFill>
+            <a:srgbClr val="F0F0F0"/>
+          </a:solidFill>
+          <a:ln>
+            <a:noFill/>
+          </a:ln>
+        </p:spPr>
+        <p:style>
+          <a:lnRef idx="1">
+            <a:schemeClr val="accent1"/>
+          </a:lnRef>
+          <a:fillRef idx="3">
+            <a:schemeClr val="accent1"/>
+          </a:fillRef>
+          <a:effectRef idx="2">
+            <a:schemeClr val="accent1"/>
+          </a:effectRef>
+          <a:fontRef idx="minor">
+            <a:schemeClr val="lt1"/>
+          </a:fontRef>
+        </p:style>
+        <p:txBody>
+          <a:bodyPr rtlCol="0" anchor="ctr"/>
+          <a:lstStyle/>
+          <a:p>
+            <a:pPr algn="ctr"/>
+          </a:p>
+        </p:txBody>
+      </p:sp>
+      <p:sp>
+        <p:nvSpPr>
+          <p:cNvPr id="7" name="TextBox 6"/>
+          <p:cNvSpPr txBox="1"/>
+          <p:nvPr/>
+        </p:nvSpPr>
+        <p:spPr>
+          <a:xfrm>
+            <a:off x="1097280" y="3340100"/>
+            <a:ext cx="640080" cy="274320"/>
+          </a:xfrm>
+          <a:prstGeom prst="rect">
+            <a:avLst/>
+          </a:prstGeom>
+          <a:noFill/>
+        </p:spPr>
+        <p:txBody>
+          <a:bodyPr wrap="square">
+            <a:spAutoFit/>
+          </a:bodyPr>
+          <a:lstStyle/>
+          <a:p>
+            <a:pPr>
+              <a:spcAft>
+                <a:spcPts val="400"/>
+              </a:spcAft>
+              <a:defRPr sz="1000">
+                <a:solidFill>
+                  <a:srgbClr val="7F7F7F"/>
+                </a:solidFill>
+              </a:defRPr>
+            </a:pPr>
+            <a:r>
+              <a:t>50%</a:t>
+            </a:r>
+          </a:p>
+        </p:txBody>
+      </p:sp>
+      <p:sp>
+        <p:nvSpPr>
+          <p:cNvPr id="8" name="Rectangle 7"/>
+          <p:cNvSpPr/>
+          <p:nvPr/>
+        </p:nvSpPr>
+        <p:spPr>
+          <a:xfrm>
+            <a:off x="1828800" y="3429000"/>
+            <a:ext cx="8686800" cy="6350"/>
+          </a:xfrm>
+          <a:prstGeom prst="rect">
+            <a:avLst/>
+          </a:prstGeom>
+          <a:solidFill>
+            <a:srgbClr val="F0F0F0"/>
+          </a:solidFill>
+          <a:ln>
+            <a:noFill/>
+          </a:ln>
+        </p:spPr>
+        <p:style>
+          <a:lnRef idx="1">
+            <a:schemeClr val="accent1"/>
+          </a:lnRef>
+          <a:fillRef idx="3">
+            <a:schemeClr val="accent1"/>
+          </a:fillRef>
+          <a:effectRef idx="2">
+            <a:schemeClr val="accent1"/>
+          </a:effectRef>
+          <a:fontRef idx="minor">
+            <a:schemeClr val="lt1"/>
+          </a:fontRef>
+        </p:style>
+        <p:txBody>
+          <a:bodyPr rtlCol="0" anchor="ctr"/>
+          <a:lstStyle/>
+          <a:p>
+            <a:pPr algn="ctr"/>
+          </a:p>
+        </p:txBody>
+      </p:sp>
+      <p:sp>
+        <p:nvSpPr>
+          <p:cNvPr id="9" name="TextBox 8"/>
+          <p:cNvSpPr txBox="1"/>
+          <p:nvPr/>
+        </p:nvSpPr>
+        <p:spPr>
+          <a:xfrm>
+            <a:off x="1097280" y="2311400"/>
+            <a:ext cx="640080" cy="274320"/>
+          </a:xfrm>
+          <a:prstGeom prst="rect">
+            <a:avLst/>
+          </a:prstGeom>
+          <a:noFill/>
+        </p:spPr>
+        <p:txBody>
+          <a:bodyPr wrap="square">
+            <a:spAutoFit/>
+          </a:bodyPr>
+          <a:lstStyle/>
+          <a:p>
+            <a:pPr>
+              <a:spcAft>
+                <a:spcPts val="400"/>
+              </a:spcAft>
+              <a:defRPr sz="1000">
+                <a:solidFill>
+                  <a:srgbClr val="7F7F7F"/>
+                </a:solidFill>
+              </a:defRPr>
+            </a:pPr>
+            <a:r>
+              <a:t>75%</a:t>
+            </a:r>
+          </a:p>
+        </p:txBody>
+      </p:sp>
+      <p:sp>
+        <p:nvSpPr>
+          <p:cNvPr id="10" name="Rectangle 9"/>
+          <p:cNvSpPr/>
+          <p:nvPr/>
+        </p:nvSpPr>
+        <p:spPr>
+          <a:xfrm>
+            <a:off x="1828800" y="2400300"/>
+            <a:ext cx="8686800" cy="6350"/>
+          </a:xfrm>
+          <a:prstGeom prst="rect">
+            <a:avLst/>
+          </a:prstGeom>
+          <a:solidFill>
+            <a:srgbClr val="F0F0F0"/>
+          </a:solidFill>
+          <a:ln>
+            <a:noFill/>
+          </a:ln>
+        </p:spPr>
+        <p:style>
+          <a:lnRef idx="1">
+            <a:schemeClr val="accent1"/>
+          </a:lnRef>
+          <a:fillRef idx="3">
+            <a:schemeClr val="accent1"/>
+          </a:fillRef>
+          <a:effectRef idx="2">
+            <a:schemeClr val="accent1"/>
+          </a:effectRef>
+          <a:fontRef idx="minor">
+            <a:schemeClr val="lt1"/>
+          </a:fontRef>
+        </p:style>
+        <p:txBody>
+          <a:bodyPr rtlCol="0" anchor="ctr"/>
+          <a:lstStyle/>
+          <a:p>
+            <a:pPr algn="ctr"/>
+          </a:p>
+        </p:txBody>
+      </p:sp>
+      <p:sp>
+        <p:nvSpPr>
+          <p:cNvPr id="11" name="TextBox 10"/>
+          <p:cNvSpPr txBox="1"/>
+          <p:nvPr/>
+        </p:nvSpPr>
+        <p:spPr>
+          <a:xfrm>
+            <a:off x="1097280" y="1282700"/>
+            <a:ext cx="640080" cy="274320"/>
+          </a:xfrm>
+          <a:prstGeom prst="rect">
+            <a:avLst/>
+          </a:prstGeom>
+          <a:noFill/>
+        </p:spPr>
+        <p:txBody>
+          <a:bodyPr wrap="square">
+            <a:spAutoFit/>
+          </a:bodyPr>
+          <a:lstStyle/>
+          <a:p>
+            <a:pPr>
+              <a:spcAft>
+                <a:spcPts val="400"/>
+              </a:spcAft>
+              <a:defRPr sz="1000">
+                <a:solidFill>
+                  <a:srgbClr val="7F7F7F"/>
+                </a:solidFill>
+              </a:defRPr>
+            </a:pPr>
+            <a:r>
+              <a:t>100%</a:t>
+            </a:r>
+          </a:p>
+        </p:txBody>
+      </p:sp>
+      <p:sp>
+        <p:nvSpPr>
+          <p:cNvPr id="12" name="Rectangle 11"/>
+          <p:cNvSpPr/>
+          <p:nvPr/>
+        </p:nvSpPr>
+        <p:spPr>
+          <a:xfrm>
+            <a:off x="1828800" y="1371600"/>
+            <a:ext cx="8686800" cy="6350"/>
+          </a:xfrm>
+          <a:prstGeom prst="rect">
+            <a:avLst/>
+          </a:prstGeom>
+          <a:solidFill>
+            <a:srgbClr val="F0F0F0"/>
+          </a:solidFill>
+          <a:ln>
+            <a:noFill/>
+          </a:ln>
+        </p:spPr>
+        <p:style>
+          <a:lnRef idx="1">
+            <a:schemeClr val="accent1"/>
+          </a:lnRef>
+          <a:fillRef idx="3">
+            <a:schemeClr val="accent1"/>
+          </a:fillRef>
+          <a:effectRef idx="2">
+            <a:schemeClr val="accent1"/>
+          </a:effectRef>
+          <a:fontRef idx="minor">
+            <a:schemeClr val="lt1"/>
+          </a:fontRef>
+        </p:style>
+        <p:txBody>
+          <a:bodyPr rtlCol="0" anchor="ctr"/>
+          <a:lstStyle/>
+          <a:p>
+            <a:pPr algn="ctr"/>
+          </a:p>
+        </p:txBody>
+      </p:sp>
+      <p:sp>
+        <p:nvSpPr>
+          <p:cNvPr id="13" name="Rectangle 12"/>
+          <p:cNvSpPr/>
+          <p:nvPr/>
+        </p:nvSpPr>
+        <p:spPr>
+          <a:xfrm>
+            <a:off x="1828800" y="4703902"/>
+            <a:ext cx="1280160" cy="782497"/>
+          </a:xfrm>
+          <a:prstGeom prst="rect">
+            <a:avLst/>
+          </a:prstGeom>
+          <a:solidFill>
+            <a:srgbClr val="2CA02C"/>
+          </a:solidFill>
+          <a:ln w="6350">
+            <a:solidFill>
+              <a:srgbClr val="FFFFFF"/>
+            </a:solidFill>
+          </a:ln>
+        </p:spPr>
+        <p:style>
+          <a:lnRef idx="1">
+            <a:schemeClr val="accent1"/>
+          </a:lnRef>
+          <a:fillRef idx="3">
+            <a:schemeClr val="accent1"/>
+          </a:fillRef>
+          <a:effectRef idx="2">
+            <a:schemeClr val="accent1"/>
+          </a:effectRef>
+          <a:fontRef idx="minor">
+            <a:schemeClr val="lt1"/>
+          </a:fontRef>
+        </p:style>
+        <p:txBody>
+          <a:bodyPr rtlCol="0" anchor="ctr" wrap="none"/>
+          <a:lstStyle/>
+          <a:p>
+            <a:pPr algn="ctr">
+              <a:spcBef>
+                <a:spcPts val="0"/>
+              </a:spcBef>
+              <a:defRPr sz="900" b="1">
+                <a:solidFill>
+                  <a:srgbClr val="FFFFFF"/>
+                </a:solidFill>
+              </a:defRPr>
+            </a:pPr>
+            <a:r>
+              <a:t>19%</a:t>
+            </a:r>
+          </a:p>
+        </p:txBody>
+      </p:sp>
+      <p:sp>
+        <p:nvSpPr>
+          <p:cNvPr id="14" name="Rectangle 13"/>
+          <p:cNvSpPr/>
+          <p:nvPr/>
+        </p:nvSpPr>
+        <p:spPr>
+          <a:xfrm>
+            <a:off x="1828800" y="4530394"/>
+            <a:ext cx="1280160" cy="173507"/>
+          </a:xfrm>
+          <a:prstGeom prst="rect">
+            <a:avLst/>
+          </a:prstGeom>
+          <a:solidFill>
+            <a:srgbClr val="FF7F0E"/>
+          </a:solidFill>
+          <a:ln w="6350">
+            <a:solidFill>
+              <a:srgbClr val="FFFFFF"/>
+            </a:solidFill>
+          </a:ln>
+        </p:spPr>
+        <p:style>
+          <a:lnRef idx="1">
+            <a:schemeClr val="accent1"/>
+          </a:lnRef>
+          <a:fillRef idx="3">
+            <a:schemeClr val="accent1"/>
+          </a:fillRef>
+          <a:effectRef idx="2">
+            <a:schemeClr val="accent1"/>
+          </a:effectRef>
+          <a:fontRef idx="minor">
+            <a:schemeClr val="lt1"/>
+          </a:fontRef>
+        </p:style>
+        <p:txBody>
+          <a:bodyPr rtlCol="0" anchor="ctr"/>
+          <a:lstStyle/>
+          <a:p>
+            <a:pPr algn="ctr"/>
+          </a:p>
+        </p:txBody>
+      </p:sp>
+      <p:sp>
+        <p:nvSpPr>
+          <p:cNvPr id="15" name="Rectangle 14"/>
+          <p:cNvSpPr/>
+          <p:nvPr/>
+        </p:nvSpPr>
+        <p:spPr>
+          <a:xfrm>
+            <a:off x="1828800" y="3437915"/>
+            <a:ext cx="1280160" cy="1092479"/>
+          </a:xfrm>
+          <a:prstGeom prst="rect">
+            <a:avLst/>
+          </a:prstGeom>
+          <a:solidFill>
+            <a:srgbClr val="1F77B4"/>
+          </a:solidFill>
+          <a:ln w="6350">
+            <a:solidFill>
+              <a:srgbClr val="FFFFFF"/>
+            </a:solidFill>
+          </a:ln>
+        </p:spPr>
+        <p:style>
+          <a:lnRef idx="1">
+            <a:schemeClr val="accent1"/>
+          </a:lnRef>
+          <a:fillRef idx="3">
+            <a:schemeClr val="accent1"/>
+          </a:fillRef>
+          <a:effectRef idx="2">
+            <a:schemeClr val="accent1"/>
+          </a:effectRef>
+          <a:fontRef idx="minor">
+            <a:schemeClr val="lt1"/>
+          </a:fontRef>
+        </p:style>
+        <p:txBody>
+          <a:bodyPr rtlCol="0" anchor="ctr" wrap="none"/>
+          <a:lstStyle/>
+          <a:p>
+            <a:pPr algn="ctr">
+              <a:spcBef>
+                <a:spcPts val="0"/>
+              </a:spcBef>
+              <a:defRPr sz="900" b="1">
+                <a:solidFill>
+                  <a:srgbClr val="FFFFFF"/>
+                </a:solidFill>
+              </a:defRPr>
+            </a:pPr>
+            <a:r>
+              <a:t>27%</a:t>
+            </a:r>
+          </a:p>
+        </p:txBody>
+      </p:sp>
+      <p:sp>
+        <p:nvSpPr>
+          <p:cNvPr id="16" name="Rectangle 15"/>
+          <p:cNvSpPr/>
+          <p:nvPr/>
+        </p:nvSpPr>
+        <p:spPr>
+          <a:xfrm>
+            <a:off x="1828800" y="1372971"/>
+            <a:ext cx="1280160" cy="2064943"/>
+          </a:xfrm>
+          <a:prstGeom prst="rect">
+            <a:avLst/>
+          </a:prstGeom>
+          <a:solidFill>
+            <a:srgbClr val="D62728"/>
+          </a:solidFill>
+          <a:ln w="6350">
+            <a:solidFill>
+              <a:srgbClr val="FFFFFF"/>
+            </a:solidFill>
+          </a:ln>
+        </p:spPr>
+        <p:style>
+          <a:lnRef idx="1">
+            <a:schemeClr val="accent1"/>
+          </a:lnRef>
+          <a:fillRef idx="3">
+            <a:schemeClr val="accent1"/>
+          </a:fillRef>
+          <a:effectRef idx="2">
+            <a:schemeClr val="accent1"/>
+          </a:effectRef>
+          <a:fontRef idx="minor">
+            <a:schemeClr val="lt1"/>
+          </a:fontRef>
+        </p:style>
+        <p:txBody>
+          <a:bodyPr rtlCol="0" anchor="ctr" wrap="none"/>
+          <a:lstStyle/>
+          <a:p>
+            <a:pPr algn="ctr">
+              <a:spcBef>
+                <a:spcPts val="0"/>
+              </a:spcBef>
+              <a:defRPr sz="900" b="1">
+                <a:solidFill>
+                  <a:srgbClr val="FFFFFF"/>
+                </a:solidFill>
+              </a:defRPr>
+            </a:pPr>
+            <a:r>
+              <a:t>50%</a:t>
+            </a:r>
+          </a:p>
+        </p:txBody>
+      </p:sp>
+      <p:sp>
+        <p:nvSpPr>
+          <p:cNvPr id="17" name="TextBox 16"/>
+          <p:cNvSpPr txBox="1"/>
+          <p:nvPr/>
+        </p:nvSpPr>
+        <p:spPr>
+          <a:xfrm>
+            <a:off x="1828800" y="5577840"/>
+            <a:ext cx="1280160" cy="365760"/>
+          </a:xfrm>
+          <a:prstGeom prst="rect">
+            <a:avLst/>
+          </a:prstGeom>
+          <a:noFill/>
+        </p:spPr>
+        <p:txBody>
+          <a:bodyPr wrap="square">
+            <a:spAutoFit/>
+          </a:bodyPr>
+          <a:lstStyle/>
+          <a:p>
+            <a:pPr>
+              <a:spcAft>
+                <a:spcPts val="400"/>
+              </a:spcAft>
+              <a:defRPr sz="1200">
+                <a:solidFill>
+                  <a:srgbClr val="2D2D2D"/>
+                </a:solidFill>
+              </a:defRPr>
+            </a:pPr>
+            <a:r>
+              <a:t>LangChain</a:t>
+            </a:r>
+          </a:p>
+        </p:txBody>
+      </p:sp>
+      <p:sp>
+        <p:nvSpPr>
+          <p:cNvPr id="18" name="Rectangle 17"/>
+          <p:cNvSpPr/>
+          <p:nvPr/>
+        </p:nvSpPr>
+        <p:spPr>
+          <a:xfrm>
+            <a:off x="3566160" y="4747793"/>
+            <a:ext cx="1280160" cy="738606"/>
+          </a:xfrm>
+          <a:prstGeom prst="rect">
+            <a:avLst/>
+          </a:prstGeom>
+          <a:solidFill>
+            <a:srgbClr val="2CA02C"/>
+          </a:solidFill>
+          <a:ln w="6350">
+            <a:solidFill>
+              <a:srgbClr val="FFFFFF"/>
+            </a:solidFill>
+          </a:ln>
+        </p:spPr>
+        <p:style>
+          <a:lnRef idx="1">
+            <a:schemeClr val="accent1"/>
+          </a:lnRef>
+          <a:fillRef idx="3">
+            <a:schemeClr val="accent1"/>
+          </a:fillRef>
+          <a:effectRef idx="2">
+            <a:schemeClr val="accent1"/>
+          </a:effectRef>
+          <a:fontRef idx="minor">
+            <a:schemeClr val="lt1"/>
+          </a:fontRef>
+        </p:style>
+        <p:txBody>
+          <a:bodyPr rtlCol="0" anchor="ctr" wrap="none"/>
+          <a:lstStyle/>
+          <a:p>
+            <a:pPr algn="ctr">
+              <a:spcBef>
+                <a:spcPts val="0"/>
+              </a:spcBef>
+              <a:defRPr sz="900" b="1">
+                <a:solidFill>
+                  <a:srgbClr val="FFFFFF"/>
+                </a:solidFill>
+              </a:defRPr>
+            </a:pPr>
+            <a:r>
+              <a:t>18%</a:t>
+            </a:r>
+          </a:p>
+        </p:txBody>
+      </p:sp>
+      <p:sp>
+        <p:nvSpPr>
+          <p:cNvPr id="19" name="Rectangle 18"/>
+          <p:cNvSpPr/>
+          <p:nvPr/>
+        </p:nvSpPr>
+        <p:spPr>
+          <a:xfrm>
+            <a:off x="3566160" y="4580458"/>
+            <a:ext cx="1280160" cy="167335"/>
+          </a:xfrm>
+          <a:prstGeom prst="rect">
+            <a:avLst/>
+          </a:prstGeom>
+          <a:solidFill>
+            <a:srgbClr val="FF7F0E"/>
+          </a:solidFill>
+          <a:ln w="6350">
+            <a:solidFill>
+              <a:srgbClr val="FFFFFF"/>
+            </a:solidFill>
+          </a:ln>
+        </p:spPr>
+        <p:style>
+          <a:lnRef idx="1">
+            <a:schemeClr val="accent1"/>
+          </a:lnRef>
+          <a:fillRef idx="3">
+            <a:schemeClr val="accent1"/>
+          </a:fillRef>
+          <a:effectRef idx="2">
+            <a:schemeClr val="accent1"/>
+          </a:effectRef>
+          <a:fontRef idx="minor">
+            <a:schemeClr val="lt1"/>
+          </a:fontRef>
+        </p:style>
+        <p:txBody>
+          <a:bodyPr rtlCol="0" anchor="ctr"/>
+          <a:lstStyle/>
+          <a:p>
+            <a:pPr algn="ctr"/>
+          </a:p>
+        </p:txBody>
+      </p:sp>
+      <p:sp>
+        <p:nvSpPr>
+          <p:cNvPr id="20" name="Rectangle 19"/>
+          <p:cNvSpPr/>
+          <p:nvPr/>
+        </p:nvSpPr>
+        <p:spPr>
+          <a:xfrm>
+            <a:off x="3566160" y="3313785"/>
+            <a:ext cx="1280160" cy="1266672"/>
+          </a:xfrm>
+          <a:prstGeom prst="rect">
+            <a:avLst/>
+          </a:prstGeom>
+          <a:solidFill>
+            <a:srgbClr val="1F77B4"/>
+          </a:solidFill>
+          <a:ln w="6350">
+            <a:solidFill>
+              <a:srgbClr val="FFFFFF"/>
+            </a:solidFill>
+          </a:ln>
+        </p:spPr>
+        <p:style>
+          <a:lnRef idx="1">
+            <a:schemeClr val="accent1"/>
+          </a:lnRef>
+          <a:fillRef idx="3">
+            <a:schemeClr val="accent1"/>
+          </a:fillRef>
+          <a:effectRef idx="2">
+            <a:schemeClr val="accent1"/>
+          </a:effectRef>
+          <a:fontRef idx="minor">
+            <a:schemeClr val="lt1"/>
+          </a:fontRef>
+        </p:style>
+        <p:txBody>
+          <a:bodyPr rtlCol="0" anchor="ctr" wrap="none"/>
+          <a:lstStyle/>
+          <a:p>
+            <a:pPr algn="ctr">
+              <a:spcBef>
+                <a:spcPts val="0"/>
+              </a:spcBef>
+              <a:defRPr sz="900" b="1">
+                <a:solidFill>
+                  <a:srgbClr val="FFFFFF"/>
+                </a:solidFill>
+              </a:defRPr>
+            </a:pPr>
+            <a:r>
+              <a:t>31%</a:t>
+            </a:r>
+          </a:p>
+        </p:txBody>
+      </p:sp>
+      <p:sp>
+        <p:nvSpPr>
+          <p:cNvPr id="21" name="Rectangle 20"/>
+          <p:cNvSpPr/>
+          <p:nvPr/>
+        </p:nvSpPr>
+        <p:spPr>
+          <a:xfrm>
+            <a:off x="3566160" y="1370914"/>
+            <a:ext cx="1280160" cy="1942871"/>
+          </a:xfrm>
+          <a:prstGeom prst="rect">
+            <a:avLst/>
+          </a:prstGeom>
+          <a:solidFill>
+            <a:srgbClr val="D62728"/>
+          </a:solidFill>
+          <a:ln w="6350">
+            <a:solidFill>
+              <a:srgbClr val="FFFFFF"/>
+            </a:solidFill>
+          </a:ln>
+        </p:spPr>
+        <p:style>
+          <a:lnRef idx="1">
+            <a:schemeClr val="accent1"/>
+          </a:lnRef>
+          <a:fillRef idx="3">
+            <a:schemeClr val="accent1"/>
+          </a:fillRef>
+          <a:effectRef idx="2">
+            <a:schemeClr val="accent1"/>
+          </a:effectRef>
+          <a:fontRef idx="minor">
+            <a:schemeClr val="lt1"/>
+          </a:fontRef>
+        </p:style>
+        <p:txBody>
+          <a:bodyPr rtlCol="0" anchor="ctr" wrap="none"/>
+          <a:lstStyle/>
+          <a:p>
+            <a:pPr algn="ctr">
+              <a:spcBef>
+                <a:spcPts val="0"/>
+              </a:spcBef>
+              <a:defRPr sz="900" b="1">
+                <a:solidFill>
+                  <a:srgbClr val="FFFFFF"/>
+                </a:solidFill>
+              </a:defRPr>
+            </a:pPr>
+            <a:r>
+              <a:t>47%</a:t>
+            </a:r>
+          </a:p>
+        </p:txBody>
+      </p:sp>
+      <p:sp>
+        <p:nvSpPr>
+          <p:cNvPr id="22" name="TextBox 21"/>
+          <p:cNvSpPr txBox="1"/>
+          <p:nvPr/>
+        </p:nvSpPr>
+        <p:spPr>
+          <a:xfrm>
+            <a:off x="3566160" y="5577840"/>
+            <a:ext cx="1280160" cy="365760"/>
+          </a:xfrm>
+          <a:prstGeom prst="rect">
+            <a:avLst/>
+          </a:prstGeom>
+          <a:noFill/>
+        </p:spPr>
+        <p:txBody>
+          <a:bodyPr wrap="square">
+            <a:spAutoFit/>
+          </a:bodyPr>
+          <a:lstStyle/>
+          <a:p>
+            <a:pPr>
+              <a:spcAft>
+                <a:spcPts val="400"/>
+              </a:spcAft>
+              <a:defRPr sz="1200">
+                <a:solidFill>
+                  <a:srgbClr val="2D2D2D"/>
+                </a:solidFill>
+              </a:defRPr>
+            </a:pPr>
+            <a:r>
+              <a:t>LangGraph</a:t>
+            </a:r>
+          </a:p>
+        </p:txBody>
+      </p:sp>
+      <p:sp>
+        <p:nvSpPr>
+          <p:cNvPr id="23" name="Rectangle 22"/>
+          <p:cNvSpPr/>
+          <p:nvPr/>
+        </p:nvSpPr>
+        <p:spPr>
+          <a:xfrm>
+            <a:off x="5303520" y="4685385"/>
+            <a:ext cx="1280160" cy="801014"/>
+          </a:xfrm>
+          <a:prstGeom prst="rect">
+            <a:avLst/>
+          </a:prstGeom>
+          <a:solidFill>
+            <a:srgbClr val="2CA02C"/>
+          </a:solidFill>
+          <a:ln w="6350">
+            <a:solidFill>
+              <a:srgbClr val="FFFFFF"/>
+            </a:solidFill>
+          </a:ln>
+        </p:spPr>
+        <p:style>
+          <a:lnRef idx="1">
+            <a:schemeClr val="accent1"/>
+          </a:lnRef>
+          <a:fillRef idx="3">
+            <a:schemeClr val="accent1"/>
+          </a:fillRef>
+          <a:effectRef idx="2">
+            <a:schemeClr val="accent1"/>
+          </a:effectRef>
+          <a:fontRef idx="minor">
+            <a:schemeClr val="lt1"/>
+          </a:fontRef>
+        </p:style>
+        <p:txBody>
+          <a:bodyPr rtlCol="0" anchor="ctr" wrap="none"/>
+          <a:lstStyle/>
+          <a:p>
+            <a:pPr algn="ctr">
+              <a:spcBef>
+                <a:spcPts val="0"/>
+              </a:spcBef>
+              <a:defRPr sz="900" b="1">
+                <a:solidFill>
+                  <a:srgbClr val="FFFFFF"/>
+                </a:solidFill>
+              </a:defRPr>
+            </a:pPr>
+            <a:r>
+              <a:t>19%</a:t>
+            </a:r>
+          </a:p>
+        </p:txBody>
+      </p:sp>
+      <p:sp>
+        <p:nvSpPr>
+          <p:cNvPr id="24" name="Rectangle 23"/>
+          <p:cNvSpPr/>
+          <p:nvPr/>
+        </p:nvSpPr>
+        <p:spPr>
+          <a:xfrm>
+            <a:off x="5303520" y="4495419"/>
+            <a:ext cx="1280160" cy="189966"/>
+          </a:xfrm>
+          <a:prstGeom prst="rect">
+            <a:avLst/>
+          </a:prstGeom>
+          <a:solidFill>
+            <a:srgbClr val="FF7F0E"/>
+          </a:solidFill>
+          <a:ln w="6350">
+            <a:solidFill>
+              <a:srgbClr val="FFFFFF"/>
+            </a:solidFill>
+          </a:ln>
+        </p:spPr>
+        <p:style>
+          <a:lnRef idx="1">
+            <a:schemeClr val="accent1"/>
+          </a:lnRef>
+          <a:fillRef idx="3">
+            <a:schemeClr val="accent1"/>
+          </a:fillRef>
+          <a:effectRef idx="2">
+            <a:schemeClr val="accent1"/>
+          </a:effectRef>
+          <a:fontRef idx="minor">
+            <a:schemeClr val="lt1"/>
+          </a:fontRef>
+        </p:style>
+        <p:txBody>
+          <a:bodyPr rtlCol="0" anchor="ctr"/>
+          <a:lstStyle/>
+          <a:p>
+            <a:pPr algn="ctr"/>
+          </a:p>
+        </p:txBody>
+      </p:sp>
+      <p:sp>
+        <p:nvSpPr>
+          <p:cNvPr id="25" name="Rectangle 24"/>
+          <p:cNvSpPr/>
+          <p:nvPr/>
+        </p:nvSpPr>
+        <p:spPr>
+          <a:xfrm>
+            <a:off x="5303520" y="3169081"/>
+            <a:ext cx="1280160" cy="1326337"/>
+          </a:xfrm>
+          <a:prstGeom prst="rect">
+            <a:avLst/>
+          </a:prstGeom>
+          <a:solidFill>
+            <a:srgbClr val="1F77B4"/>
+          </a:solidFill>
+          <a:ln w="6350">
+            <a:solidFill>
+              <a:srgbClr val="FFFFFF"/>
+            </a:solidFill>
+          </a:ln>
+        </p:spPr>
+        <p:style>
+          <a:lnRef idx="1">
+            <a:schemeClr val="accent1"/>
+          </a:lnRef>
+          <a:fillRef idx="3">
+            <a:schemeClr val="accent1"/>
+          </a:fillRef>
+          <a:effectRef idx="2">
+            <a:schemeClr val="accent1"/>
+          </a:effectRef>
+          <a:fontRef idx="minor">
+            <a:schemeClr val="lt1"/>
+          </a:fontRef>
+        </p:style>
+        <p:txBody>
+          <a:bodyPr rtlCol="0" anchor="ctr" wrap="none"/>
+          <a:lstStyle/>
+          <a:p>
+            <a:pPr algn="ctr">
+              <a:spcBef>
+                <a:spcPts val="0"/>
+              </a:spcBef>
+              <a:defRPr sz="900" b="1">
+                <a:solidFill>
+                  <a:srgbClr val="FFFFFF"/>
+                </a:solidFill>
+              </a:defRPr>
+            </a:pPr>
+            <a:r>
+              <a:t>32%</a:t>
+            </a:r>
+          </a:p>
+        </p:txBody>
+      </p:sp>
+      <p:sp>
+        <p:nvSpPr>
+          <p:cNvPr id="26" name="Rectangle 25"/>
+          <p:cNvSpPr/>
+          <p:nvPr/>
+        </p:nvSpPr>
+        <p:spPr>
+          <a:xfrm>
+            <a:off x="5303520" y="1371599"/>
+            <a:ext cx="1280160" cy="1797481"/>
+          </a:xfrm>
+          <a:prstGeom prst="rect">
+            <a:avLst/>
+          </a:prstGeom>
+          <a:solidFill>
+            <a:srgbClr val="D62728"/>
+          </a:solidFill>
+          <a:ln w="6350">
+            <a:solidFill>
+              <a:srgbClr val="FFFFFF"/>
+            </a:solidFill>
+          </a:ln>
+        </p:spPr>
+        <p:style>
+          <a:lnRef idx="1">
+            <a:schemeClr val="accent1"/>
+          </a:lnRef>
+          <a:fillRef idx="3">
+            <a:schemeClr val="accent1"/>
+          </a:fillRef>
+          <a:effectRef idx="2">
+            <a:schemeClr val="accent1"/>
+          </a:effectRef>
+          <a:fontRef idx="minor">
+            <a:schemeClr val="lt1"/>
+          </a:fontRef>
+        </p:style>
+        <p:txBody>
+          <a:bodyPr rtlCol="0" anchor="ctr" wrap="none"/>
+          <a:lstStyle/>
+          <a:p>
+            <a:pPr algn="ctr">
+              <a:spcBef>
+                <a:spcPts val="0"/>
+              </a:spcBef>
+              <a:defRPr sz="900" b="1">
+                <a:solidFill>
+                  <a:srgbClr val="FFFFFF"/>
+                </a:solidFill>
+              </a:defRPr>
+            </a:pPr>
+            <a:r>
+              <a:t>44%</a:t>
+            </a:r>
+          </a:p>
+        </p:txBody>
+      </p:sp>
+      <p:sp>
+        <p:nvSpPr>
+          <p:cNvPr id="27" name="TextBox 26"/>
+          <p:cNvSpPr txBox="1"/>
+          <p:nvPr/>
+        </p:nvSpPr>
+        <p:spPr>
+          <a:xfrm>
+            <a:off x="5303520" y="5577840"/>
+            <a:ext cx="1280160" cy="365760"/>
+          </a:xfrm>
+          <a:prstGeom prst="rect">
+            <a:avLst/>
+          </a:prstGeom>
+          <a:noFill/>
+        </p:spPr>
+        <p:txBody>
+          <a:bodyPr wrap="square">
+            <a:spAutoFit/>
+          </a:bodyPr>
+          <a:lstStyle/>
+          <a:p>
+            <a:pPr>
+              <a:spcAft>
+                <a:spcPts val="400"/>
+              </a:spcAft>
+              <a:defRPr sz="1200">
+                <a:solidFill>
+                  <a:srgbClr val="2D2D2D"/>
+                </a:solidFill>
+              </a:defRPr>
+            </a:pPr>
+            <a:r>
+              <a:t>AutoGen</a:t>
+            </a:r>
+          </a:p>
+        </p:txBody>
+      </p:sp>
+      <p:sp>
+        <p:nvSpPr>
+          <p:cNvPr id="28" name="Rectangle 27"/>
+          <p:cNvSpPr/>
+          <p:nvPr/>
+        </p:nvSpPr>
+        <p:spPr>
+          <a:xfrm>
+            <a:off x="7040880" y="4577715"/>
+            <a:ext cx="1280160" cy="908685"/>
+          </a:xfrm>
+          <a:prstGeom prst="rect">
+            <a:avLst/>
+          </a:prstGeom>
+          <a:solidFill>
+            <a:srgbClr val="2CA02C"/>
+          </a:solidFill>
+          <a:ln w="6350">
+            <a:solidFill>
+              <a:srgbClr val="FFFFFF"/>
+            </a:solidFill>
+          </a:ln>
+        </p:spPr>
+        <p:style>
+          <a:lnRef idx="1">
+            <a:schemeClr val="accent1"/>
+          </a:lnRef>
+          <a:fillRef idx="3">
+            <a:schemeClr val="accent1"/>
+          </a:fillRef>
+          <a:effectRef idx="2">
+            <a:schemeClr val="accent1"/>
+          </a:effectRef>
+          <a:fontRef idx="minor">
+            <a:schemeClr val="lt1"/>
+          </a:fontRef>
+        </p:style>
+        <p:txBody>
+          <a:bodyPr rtlCol="0" anchor="ctr" wrap="none"/>
+          <a:lstStyle/>
+          <a:p>
+            <a:pPr algn="ctr">
+              <a:spcBef>
+                <a:spcPts val="0"/>
+              </a:spcBef>
+              <a:defRPr sz="900" b="1">
+                <a:solidFill>
+                  <a:srgbClr val="FFFFFF"/>
+                </a:solidFill>
+              </a:defRPr>
+            </a:pPr>
+            <a:r>
+              <a:t>22%</a:t>
+            </a:r>
+          </a:p>
+        </p:txBody>
+      </p:sp>
+      <p:sp>
+        <p:nvSpPr>
+          <p:cNvPr id="29" name="Rectangle 28"/>
+          <p:cNvSpPr/>
+          <p:nvPr/>
+        </p:nvSpPr>
+        <p:spPr>
+          <a:xfrm>
+            <a:off x="7040880" y="4376089"/>
+            <a:ext cx="1280160" cy="201625"/>
+          </a:xfrm>
+          <a:prstGeom prst="rect">
+            <a:avLst/>
+          </a:prstGeom>
+          <a:solidFill>
+            <a:srgbClr val="FF7F0E"/>
+          </a:solidFill>
+          <a:ln w="6350">
+            <a:solidFill>
+              <a:srgbClr val="FFFFFF"/>
+            </a:solidFill>
+          </a:ln>
+        </p:spPr>
+        <p:style>
+          <a:lnRef idx="1">
+            <a:schemeClr val="accent1"/>
+          </a:lnRef>
+          <a:fillRef idx="3">
+            <a:schemeClr val="accent1"/>
+          </a:fillRef>
+          <a:effectRef idx="2">
+            <a:schemeClr val="accent1"/>
+          </a:effectRef>
+          <a:fontRef idx="minor">
+            <a:schemeClr val="lt1"/>
+          </a:fontRef>
+        </p:style>
+        <p:txBody>
+          <a:bodyPr rtlCol="0" anchor="ctr"/>
+          <a:lstStyle/>
+          <a:p>
+            <a:pPr algn="ctr"/>
+          </a:p>
+        </p:txBody>
+      </p:sp>
+      <p:sp>
+        <p:nvSpPr>
+          <p:cNvPr id="30" name="Rectangle 29"/>
+          <p:cNvSpPr/>
+          <p:nvPr/>
+        </p:nvSpPr>
+        <p:spPr>
+          <a:xfrm>
+            <a:off x="7040880" y="3200628"/>
+            <a:ext cx="1280160" cy="1175461"/>
+          </a:xfrm>
+          <a:prstGeom prst="rect">
+            <a:avLst/>
+          </a:prstGeom>
+          <a:solidFill>
+            <a:srgbClr val="1F77B4"/>
+          </a:solidFill>
+          <a:ln w="6350">
+            <a:solidFill>
+              <a:srgbClr val="FFFFFF"/>
+            </a:solidFill>
+          </a:ln>
+        </p:spPr>
+        <p:style>
+          <a:lnRef idx="1">
+            <a:schemeClr val="accent1"/>
+          </a:lnRef>
+          <a:fillRef idx="3">
+            <a:schemeClr val="accent1"/>
+          </a:fillRef>
+          <a:effectRef idx="2">
+            <a:schemeClr val="accent1"/>
+          </a:effectRef>
+          <a:fontRef idx="minor">
+            <a:schemeClr val="lt1"/>
+          </a:fontRef>
+        </p:style>
+        <p:txBody>
+          <a:bodyPr rtlCol="0" anchor="ctr" wrap="none"/>
+          <a:lstStyle/>
+          <a:p>
+            <a:pPr algn="ctr">
+              <a:spcBef>
+                <a:spcPts val="0"/>
+              </a:spcBef>
+              <a:defRPr sz="900" b="1">
+                <a:solidFill>
+                  <a:srgbClr val="FFFFFF"/>
+                </a:solidFill>
+              </a:defRPr>
+            </a:pPr>
+            <a:r>
+              <a:t>29%</a:t>
+            </a:r>
+          </a:p>
+        </p:txBody>
+      </p:sp>
+      <p:sp>
+        <p:nvSpPr>
+          <p:cNvPr id="31" name="Rectangle 30"/>
+          <p:cNvSpPr/>
+          <p:nvPr/>
+        </p:nvSpPr>
+        <p:spPr>
+          <a:xfrm>
+            <a:off x="7040880" y="1370914"/>
+            <a:ext cx="1280160" cy="1829714"/>
+          </a:xfrm>
+          <a:prstGeom prst="rect">
+            <a:avLst/>
+          </a:prstGeom>
+          <a:solidFill>
+            <a:srgbClr val="D62728"/>
+          </a:solidFill>
+          <a:ln w="6350">
+            <a:solidFill>
+              <a:srgbClr val="FFFFFF"/>
+            </a:solidFill>
+          </a:ln>
+        </p:spPr>
+        <p:style>
+          <a:lnRef idx="1">
+            <a:schemeClr val="accent1"/>
+          </a:lnRef>
+          <a:fillRef idx="3">
+            <a:schemeClr val="accent1"/>
+          </a:fillRef>
+          <a:effectRef idx="2">
+            <a:schemeClr val="accent1"/>
+          </a:effectRef>
+          <a:fontRef idx="minor">
+            <a:schemeClr val="lt1"/>
+          </a:fontRef>
+        </p:style>
+        <p:txBody>
+          <a:bodyPr rtlCol="0" anchor="ctr" wrap="none"/>
+          <a:lstStyle/>
+          <a:p>
+            <a:pPr algn="ctr">
+              <a:spcBef>
+                <a:spcPts val="0"/>
+              </a:spcBef>
+              <a:defRPr sz="900" b="1">
+                <a:solidFill>
+                  <a:srgbClr val="FFFFFF"/>
+                </a:solidFill>
+              </a:defRPr>
+            </a:pPr>
+            <a:r>
+              <a:t>44%</a:t>
+            </a:r>
+          </a:p>
+        </p:txBody>
+      </p:sp>
+      <p:sp>
+        <p:nvSpPr>
+          <p:cNvPr id="32" name="TextBox 31"/>
+          <p:cNvSpPr txBox="1"/>
+          <p:nvPr/>
+        </p:nvSpPr>
+        <p:spPr>
+          <a:xfrm>
+            <a:off x="7040880" y="5577840"/>
+            <a:ext cx="1280160" cy="365760"/>
+          </a:xfrm>
+          <a:prstGeom prst="rect">
+            <a:avLst/>
+          </a:prstGeom>
+          <a:noFill/>
+        </p:spPr>
+        <p:txBody>
+          <a:bodyPr wrap="square">
+            <a:spAutoFit/>
+          </a:bodyPr>
+          <a:lstStyle/>
+          <a:p>
+            <a:pPr>
+              <a:spcAft>
+                <a:spcPts val="400"/>
+              </a:spcAft>
+              <a:defRPr sz="1200">
+                <a:solidFill>
+                  <a:srgbClr val="2D2D2D"/>
+                </a:solidFill>
+              </a:defRPr>
+            </a:pPr>
+            <a:r>
+              <a:t>Haystack</a:t>
+            </a:r>
+          </a:p>
+        </p:txBody>
+      </p:sp>
+      <p:sp>
+        <p:nvSpPr>
+          <p:cNvPr id="33" name="Rectangle 32"/>
+          <p:cNvSpPr/>
+          <p:nvPr/>
+        </p:nvSpPr>
+        <p:spPr>
+          <a:xfrm>
+            <a:off x="8778240" y="4666869"/>
+            <a:ext cx="1280160" cy="819531"/>
+          </a:xfrm>
+          <a:prstGeom prst="rect">
+            <a:avLst/>
+          </a:prstGeom>
+          <a:solidFill>
+            <a:srgbClr val="2CA02C"/>
+          </a:solidFill>
+          <a:ln w="6350">
+            <a:solidFill>
+              <a:srgbClr val="FFFFFF"/>
+            </a:solidFill>
+          </a:ln>
+        </p:spPr>
+        <p:style>
+          <a:lnRef idx="1">
+            <a:schemeClr val="accent1"/>
+          </a:lnRef>
+          <a:fillRef idx="3">
+            <a:schemeClr val="accent1"/>
+          </a:fillRef>
+          <a:effectRef idx="2">
+            <a:schemeClr val="accent1"/>
+          </a:effectRef>
+          <a:fontRef idx="minor">
+            <a:schemeClr val="lt1"/>
+          </a:fontRef>
+        </p:style>
+        <p:txBody>
+          <a:bodyPr rtlCol="0" anchor="ctr" wrap="none"/>
+          <a:lstStyle/>
+          <a:p>
+            <a:pPr algn="ctr">
+              <a:spcBef>
+                <a:spcPts val="0"/>
+              </a:spcBef>
+              <a:defRPr sz="900" b="1">
+                <a:solidFill>
+                  <a:srgbClr val="FFFFFF"/>
+                </a:solidFill>
+              </a:defRPr>
+            </a:pPr>
+            <a:r>
+              <a:t>20%</a:t>
+            </a:r>
+          </a:p>
+        </p:txBody>
+      </p:sp>
+      <p:sp>
+        <p:nvSpPr>
+          <p:cNvPr id="34" name="Rectangle 33"/>
+          <p:cNvSpPr/>
+          <p:nvPr/>
+        </p:nvSpPr>
+        <p:spPr>
+          <a:xfrm>
+            <a:off x="8778240" y="4480331"/>
+            <a:ext cx="1280160" cy="186537"/>
+          </a:xfrm>
+          <a:prstGeom prst="rect">
+            <a:avLst/>
+          </a:prstGeom>
+          <a:solidFill>
+            <a:srgbClr val="FF7F0E"/>
+          </a:solidFill>
+          <a:ln w="6350">
+            <a:solidFill>
+              <a:srgbClr val="FFFFFF"/>
+            </a:solidFill>
+          </a:ln>
+        </p:spPr>
+        <p:style>
+          <a:lnRef idx="1">
+            <a:schemeClr val="accent1"/>
+          </a:lnRef>
+          <a:fillRef idx="3">
+            <a:schemeClr val="accent1"/>
+          </a:fillRef>
+          <a:effectRef idx="2">
+            <a:schemeClr val="accent1"/>
+          </a:effectRef>
+          <a:fontRef idx="minor">
+            <a:schemeClr val="lt1"/>
+          </a:fontRef>
+        </p:style>
+        <p:txBody>
+          <a:bodyPr rtlCol="0" anchor="ctr"/>
+          <a:lstStyle/>
+          <a:p>
+            <a:pPr algn="ctr"/>
+          </a:p>
+        </p:txBody>
+      </p:sp>
+      <p:sp>
+        <p:nvSpPr>
+          <p:cNvPr id="35" name="Rectangle 34"/>
+          <p:cNvSpPr/>
+          <p:nvPr/>
+        </p:nvSpPr>
+        <p:spPr>
+          <a:xfrm>
+            <a:off x="8778240" y="3382365"/>
+            <a:ext cx="1280160" cy="1097965"/>
+          </a:xfrm>
+          <a:prstGeom prst="rect">
+            <a:avLst/>
+          </a:prstGeom>
+          <a:solidFill>
+            <a:srgbClr val="1F77B4"/>
+          </a:solidFill>
+          <a:ln w="6350">
+            <a:solidFill>
+              <a:srgbClr val="FFFFFF"/>
+            </a:solidFill>
+          </a:ln>
+        </p:spPr>
+        <p:style>
+          <a:lnRef idx="1">
+            <a:schemeClr val="accent1"/>
+          </a:lnRef>
+          <a:fillRef idx="3">
+            <a:schemeClr val="accent1"/>
+          </a:fillRef>
+          <a:effectRef idx="2">
+            <a:schemeClr val="accent1"/>
+          </a:effectRef>
+          <a:fontRef idx="minor">
+            <a:schemeClr val="lt1"/>
+          </a:fontRef>
+        </p:style>
+        <p:txBody>
+          <a:bodyPr rtlCol="0" anchor="ctr" wrap="none"/>
+          <a:lstStyle/>
+          <a:p>
+            <a:pPr algn="ctr">
+              <a:spcBef>
+                <a:spcPts val="0"/>
+              </a:spcBef>
+              <a:defRPr sz="900" b="1">
+                <a:solidFill>
+                  <a:srgbClr val="FFFFFF"/>
+                </a:solidFill>
+              </a:defRPr>
+            </a:pPr>
+            <a:r>
+              <a:t>27%</a:t>
+            </a:r>
+          </a:p>
+        </p:txBody>
+      </p:sp>
+      <p:sp>
+        <p:nvSpPr>
+          <p:cNvPr id="36" name="Rectangle 35"/>
+          <p:cNvSpPr/>
+          <p:nvPr/>
+        </p:nvSpPr>
+        <p:spPr>
+          <a:xfrm>
+            <a:off x="8778240" y="1371600"/>
+            <a:ext cx="1280160" cy="2010765"/>
+          </a:xfrm>
+          <a:prstGeom prst="rect">
+            <a:avLst/>
+          </a:prstGeom>
+          <a:solidFill>
+            <a:srgbClr val="D62728"/>
+          </a:solidFill>
+          <a:ln w="6350">
+            <a:solidFill>
+              <a:srgbClr val="FFFFFF"/>
+            </a:solidFill>
+          </a:ln>
+        </p:spPr>
+        <p:style>
+          <a:lnRef idx="1">
+            <a:schemeClr val="accent1"/>
+          </a:lnRef>
+          <a:fillRef idx="3">
+            <a:schemeClr val="accent1"/>
+          </a:fillRef>
+          <a:effectRef idx="2">
+            <a:schemeClr val="accent1"/>
+          </a:effectRef>
+          <a:fontRef idx="minor">
+            <a:schemeClr val="lt1"/>
+          </a:fontRef>
+        </p:style>
+        <p:txBody>
+          <a:bodyPr rtlCol="0" anchor="ctr" wrap="none"/>
+          <a:lstStyle/>
+          <a:p>
+            <a:pPr algn="ctr">
+              <a:spcBef>
+                <a:spcPts val="0"/>
+              </a:spcBef>
+              <a:defRPr sz="900" b="1">
+                <a:solidFill>
+                  <a:srgbClr val="FFFFFF"/>
+                </a:solidFill>
+              </a:defRPr>
+            </a:pPr>
+            <a:r>
+              <a:t>49%</a:t>
+            </a:r>
+          </a:p>
+        </p:txBody>
+      </p:sp>
+      <p:sp>
+        <p:nvSpPr>
+          <p:cNvPr id="37" name="TextBox 36"/>
+          <p:cNvSpPr txBox="1"/>
+          <p:nvPr/>
+        </p:nvSpPr>
+        <p:spPr>
+          <a:xfrm>
+            <a:off x="8778240" y="5577840"/>
+            <a:ext cx="1280160" cy="365760"/>
+          </a:xfrm>
+          <a:prstGeom prst="rect">
+            <a:avLst/>
+          </a:prstGeom>
+          <a:noFill/>
+        </p:spPr>
+        <p:txBody>
+          <a:bodyPr wrap="square">
+            <a:spAutoFit/>
+          </a:bodyPr>
+          <a:lstStyle/>
+          <a:p>
+            <a:pPr>
+              <a:spcAft>
+                <a:spcPts val="400"/>
+              </a:spcAft>
+              <a:defRPr sz="1200">
+                <a:solidFill>
+                  <a:srgbClr val="2D2D2D"/>
+                </a:solidFill>
+              </a:defRPr>
+            </a:pPr>
+            <a:r>
+              <a:t>SWE-Agent</a:t>
+            </a:r>
+          </a:p>
+        </p:txBody>
+      </p:sp>
+      <p:sp>
+        <p:nvSpPr>
+          <p:cNvPr id="38" name="Rectangle 37"/>
+          <p:cNvSpPr/>
+          <p:nvPr/>
+        </p:nvSpPr>
+        <p:spPr>
+          <a:xfrm>
+            <a:off x="9144000" y="1188720"/>
+            <a:ext cx="228600" cy="182880"/>
+          </a:xfrm>
+          <a:prstGeom prst="rect">
+            <a:avLst/>
+          </a:prstGeom>
+          <a:solidFill>
+            <a:srgbClr val="2CA02C"/>
+          </a:solidFill>
+          <a:ln>
+            <a:noFill/>
+          </a:ln>
+        </p:spPr>
+        <p:style>
+          <a:lnRef idx="1">
+            <a:schemeClr val="accent1"/>
+          </a:lnRef>
+          <a:fillRef idx="3">
+            <a:schemeClr val="accent1"/>
+          </a:fillRef>
+          <a:effectRef idx="2">
+            <a:schemeClr val="accent1"/>
+          </a:effectRef>
+          <a:fontRef idx="minor">
+            <a:schemeClr val="lt1"/>
+          </a:fontRef>
+        </p:style>
+        <p:txBody>
+          <a:bodyPr rtlCol="0" anchor="ctr"/>
+          <a:lstStyle/>
+          <a:p>
+            <a:pPr algn="ctr"/>
+          </a:p>
+        </p:txBody>
+      </p:sp>
+      <p:sp>
+        <p:nvSpPr>
+          <p:cNvPr id="39" name="TextBox 38"/>
+          <p:cNvSpPr txBox="1"/>
+          <p:nvPr/>
+        </p:nvSpPr>
+        <p:spPr>
+          <a:xfrm>
+            <a:off x="9464040" y="1163320"/>
+            <a:ext cx="1828800" cy="274320"/>
+          </a:xfrm>
+          <a:prstGeom prst="rect">
+            <a:avLst/>
+          </a:prstGeom>
+          <a:noFill/>
+        </p:spPr>
+        <p:txBody>
+          <a:bodyPr wrap="square">
+            <a:spAutoFit/>
+          </a:bodyPr>
+          <a:lstStyle/>
+          <a:p>
+            <a:pPr>
+              <a:spcAft>
+                <a:spcPts val="400"/>
+              </a:spcAft>
+              <a:defRPr sz="1100">
+                <a:solidFill>
+                  <a:srgbClr val="2D2D2D"/>
+                </a:solidFill>
+              </a:defRPr>
+            </a:pPr>
+            <a:r>
+              <a:t>Retiring</a:t>
+            </a:r>
+          </a:p>
+        </p:txBody>
+      </p:sp>
+      <p:sp>
+        <p:nvSpPr>
+          <p:cNvPr id="40" name="Rectangle 39"/>
+          <p:cNvSpPr/>
+          <p:nvPr/>
+        </p:nvSpPr>
+        <p:spPr>
+          <a:xfrm>
+            <a:off x="9144000" y="1508760"/>
+            <a:ext cx="228600" cy="182880"/>
+          </a:xfrm>
+          <a:prstGeom prst="rect">
+            <a:avLst/>
+          </a:prstGeom>
+          <a:solidFill>
+            <a:srgbClr val="FF7F0E"/>
+          </a:solidFill>
+          <a:ln>
+            <a:noFill/>
+          </a:ln>
+        </p:spPr>
+        <p:style>
+          <a:lnRef idx="1">
+            <a:schemeClr val="accent1"/>
+          </a:lnRef>
+          <a:fillRef idx="3">
+            <a:schemeClr val="accent1"/>
+          </a:fillRef>
+          <a:effectRef idx="2">
+            <a:schemeClr val="accent1"/>
+          </a:effectRef>
+          <a:fontRef idx="minor">
+            <a:schemeClr val="lt1"/>
+          </a:fontRef>
+        </p:style>
+        <p:txBody>
+          <a:bodyPr rtlCol="0" anchor="ctr"/>
+          <a:lstStyle/>
+          <a:p>
+            <a:pPr algn="ctr"/>
+          </a:p>
+        </p:txBody>
+      </p:sp>
+      <p:sp>
+        <p:nvSpPr>
+          <p:cNvPr id="41" name="TextBox 40"/>
+          <p:cNvSpPr txBox="1"/>
+          <p:nvPr/>
+        </p:nvSpPr>
+        <p:spPr>
+          <a:xfrm>
+            <a:off x="9464040" y="1483360"/>
+            <a:ext cx="1828800" cy="274320"/>
+          </a:xfrm>
+          <a:prstGeom prst="rect">
+            <a:avLst/>
+          </a:prstGeom>
+          <a:noFill/>
+        </p:spPr>
+        <p:txBody>
+          <a:bodyPr wrap="square">
+            <a:spAutoFit/>
+          </a:bodyPr>
+          <a:lstStyle/>
+          <a:p>
+            <a:pPr>
+              <a:spcAft>
+                <a:spcPts val="400"/>
+              </a:spcAft>
+              <a:defRPr sz="1100">
+                <a:solidFill>
+                  <a:srgbClr val="2D2D2D"/>
+                </a:solidFill>
+              </a:defRPr>
+            </a:pPr>
+            <a:r>
+              <a:t>Bad Speculation</a:t>
+            </a:r>
+          </a:p>
+        </p:txBody>
+      </p:sp>
+      <p:sp>
+        <p:nvSpPr>
+          <p:cNvPr id="42" name="Rectangle 41"/>
+          <p:cNvSpPr/>
+          <p:nvPr/>
+        </p:nvSpPr>
+        <p:spPr>
+          <a:xfrm>
+            <a:off x="9144000" y="1828800"/>
+            <a:ext cx="228600" cy="182880"/>
+          </a:xfrm>
+          <a:prstGeom prst="rect">
+            <a:avLst/>
+          </a:prstGeom>
+          <a:solidFill>
+            <a:srgbClr val="1F77B4"/>
+          </a:solidFill>
+          <a:ln>
+            <a:noFill/>
+          </a:ln>
+        </p:spPr>
+        <p:style>
+          <a:lnRef idx="1">
+            <a:schemeClr val="accent1"/>
+          </a:lnRef>
+          <a:fillRef idx="3">
+            <a:schemeClr val="accent1"/>
+          </a:fillRef>
+          <a:effectRef idx="2">
+            <a:schemeClr val="accent1"/>
+          </a:effectRef>
+          <a:fontRef idx="minor">
+            <a:schemeClr val="lt1"/>
+          </a:fontRef>
+        </p:style>
+        <p:txBody>
+          <a:bodyPr rtlCol="0" anchor="ctr"/>
+          <a:lstStyle/>
+          <a:p>
+            <a:pPr algn="ctr"/>
+          </a:p>
+        </p:txBody>
+      </p:sp>
+      <p:sp>
+        <p:nvSpPr>
+          <p:cNvPr id="43" name="TextBox 42"/>
+          <p:cNvSpPr txBox="1"/>
+          <p:nvPr/>
+        </p:nvSpPr>
+        <p:spPr>
+          <a:xfrm>
+            <a:off x="9464040" y="1803400"/>
+            <a:ext cx="1828800" cy="274320"/>
+          </a:xfrm>
+          <a:prstGeom prst="rect">
+            <a:avLst/>
+          </a:prstGeom>
+          <a:noFill/>
+        </p:spPr>
+        <p:txBody>
+          <a:bodyPr wrap="square">
+            <a:spAutoFit/>
+          </a:bodyPr>
+          <a:lstStyle/>
+          <a:p>
+            <a:pPr>
+              <a:spcAft>
+                <a:spcPts val="400"/>
+              </a:spcAft>
+              <a:defRPr sz="1100">
+                <a:solidFill>
+                  <a:srgbClr val="2D2D2D"/>
+                </a:solidFill>
+              </a:defRPr>
+            </a:pPr>
+            <a:r>
+              <a:t>Frontend Bound</a:t>
+            </a:r>
+          </a:p>
+        </p:txBody>
+      </p:sp>
+      <p:sp>
+        <p:nvSpPr>
+          <p:cNvPr id="44" name="Rectangle 43"/>
+          <p:cNvSpPr/>
+          <p:nvPr/>
+        </p:nvSpPr>
+        <p:spPr>
+          <a:xfrm>
+            <a:off x="9144000" y="2148840"/>
+            <a:ext cx="228600" cy="182880"/>
+          </a:xfrm>
+          <a:prstGeom prst="rect">
+            <a:avLst/>
+          </a:prstGeom>
+          <a:solidFill>
+            <a:srgbClr val="D62728"/>
+          </a:solidFill>
+          <a:ln>
+            <a:noFill/>
+          </a:ln>
+        </p:spPr>
+        <p:style>
+          <a:lnRef idx="1">
+            <a:schemeClr val="accent1"/>
+          </a:lnRef>
+          <a:fillRef idx="3">
+            <a:schemeClr val="accent1"/>
+          </a:fillRef>
+          <a:effectRef idx="2">
+            <a:schemeClr val="accent1"/>
+          </a:effectRef>
+          <a:fontRef idx="minor">
+            <a:schemeClr val="lt1"/>
+          </a:fontRef>
+        </p:style>
+        <p:txBody>
+          <a:bodyPr rtlCol="0" anchor="ctr"/>
+          <a:lstStyle/>
+          <a:p>
+            <a:pPr algn="ctr"/>
+          </a:p>
+        </p:txBody>
+      </p:sp>
+      <p:sp>
+        <p:nvSpPr>
+          <p:cNvPr id="45" name="TextBox 44"/>
+          <p:cNvSpPr txBox="1"/>
+          <p:nvPr/>
+        </p:nvSpPr>
+        <p:spPr>
+          <a:xfrm>
+            <a:off x="9464040" y="2123440"/>
+            <a:ext cx="1828800" cy="274320"/>
+          </a:xfrm>
+          <a:prstGeom prst="rect">
+            <a:avLst/>
+          </a:prstGeom>
+          <a:noFill/>
+        </p:spPr>
+        <p:txBody>
+          <a:bodyPr wrap="square">
+            <a:spAutoFit/>
+          </a:bodyPr>
+          <a:lstStyle/>
+          <a:p>
+            <a:pPr>
+              <a:spcAft>
+                <a:spcPts val="400"/>
+              </a:spcAft>
+              <a:defRPr sz="1100">
+                <a:solidFill>
+                  <a:srgbClr val="2D2D2D"/>
+                </a:solidFill>
+              </a:defRPr>
+            </a:pPr>
+            <a:r>
+              <a:t>Backend Bound</a:t>
+            </a:r>
+          </a:p>
+        </p:txBody>
+      </p:sp>
     </p:spTree>
   </p:cSld>
   <p:clrMapOvr>

</xml_diff>

<commit_message>
Update DR fixes slide with dynamo_initialized-gated safe_read guard
</commit_message>
<xml_diff>
--- a/docs/agent_cpu_evaluation.pptx
+++ b/docs/agent_cpu_evaluation.pptx
@@ -3372,7 +3372,7 @@
               </a:defRPr>
             </a:pPr>
             <a:r>
-              <a:t>Root Cause 1: SIGSEGV crash — race in module_list_remove() (core/module_list.c)</a:t>
+              <a:t>Root Cause 1: SIGSEGV crash — stale module name pointers in multi-threaded workloads</a:t>
             </a:r>
           </a:p>
           <a:p>
@@ -3387,7 +3387,7 @@
               </a:defRPr>
             </a:pPr>
             <a:r>
-              <a:t>module_list_remove() released write lock for client callback, module still in vmvector</a:t>
+              <a:t>Thread A frees module data via module_list_remove() while Thread B holds a stale pointer</a:t>
             </a:r>
           </a:p>
           <a:p>
@@ -3402,7 +3402,7 @@
               </a:defRPr>
             </a:pPr>
             <a:r>
-              <a:t>Another thread gets module name pointer via vmvector_lookup during this window</a:t>
+              <a:t>Thread B calls d_r_strcmp on freed memory → SIGSEGV</a:t>
             </a:r>
           </a:p>
           <a:p>
@@ -3417,7 +3417,7 @@
               </a:defRPr>
             </a:pPr>
             <a:r>
-              <a:t>First thread re-acquires lock, frees module data → second thread's pointer is stale → SIGSEGV</a:t>
+              <a:t>Multiple race windows: module_list_remove lock release, and read-lock-then-release patterns</a:t>
             </a:r>
           </a:p>
           <a:p>
@@ -3478,6 +3478,33 @@
             </a:r>
           </a:p>
           <a:p>
+            <a:pPr>
+              <a:spcAft>
+                <a:spcPts val="300"/>
+              </a:spcAft>
+              <a:defRPr sz="1300">
+                <a:solidFill>
+                  <a:srgbClr val="2D2D2D"/>
+                </a:solidFill>
+              </a:defRPr>
+            </a:pPr>
+          </a:p>
+          <a:p>
+            <a:pPr>
+              <a:spcAft>
+                <a:spcPts val="300"/>
+              </a:spcAft>
+              <a:defRPr sz="1300">
+                <a:solidFill>
+                  <a:srgbClr val="2D2D2D"/>
+                </a:solidFill>
+              </a:defRPr>
+            </a:pPr>
+            <a:r>
+              <a:t>Fix 1 (for RC1): d_r_strcmp safe_read guard, gated on dynamo_initialized (core/string.c)</a:t>
+            </a:r>
+          </a:p>
+          <a:p>
             <a:pPr lvl="1">
               <a:spcAft>
                 <a:spcPts val="300"/>
@@ -3489,7 +3516,37 @@
               </a:defRPr>
             </a:pPr>
             <a:r>
-              <a:t>Wrong config → libfpg.so client not loaded → empty fingerprint output</a:t>
+              <a:t>d_r_safe_read() probe before dereferencing — returns 0 (equal) on stale pointers</a:t>
+            </a:r>
+          </a:p>
+          <a:p>
+            <a:pPr lvl="1">
+              <a:spcAft>
+                <a:spcPts val="300"/>
+              </a:spcAft>
+              <a:defRPr sz="1300">
+                <a:solidFill>
+                  <a:srgbClr val="2D2D2D"/>
+                </a:solidFill>
+              </a:defRPr>
+            </a:pPr>
+            <a:r>
+              <a:t>Gated on dynamo_initialized: safe_read uses signal handlers, not available during early init</a:t>
+            </a:r>
+          </a:p>
+          <a:p>
+            <a:pPr lvl="1">
+              <a:spcAft>
+                <a:spcPts val="300"/>
+              </a:spcAft>
+              <a:defRPr sz="1300">
+                <a:solidFill>
+                  <a:srgbClr val="2D2D2D"/>
+                </a:solidFill>
+              </a:defRPr>
+            </a:pPr>
+            <a:r>
+              <a:t>Before init: direct comparison (no guard). After init: safe_read guard active</a:t>
             </a:r>
           </a:p>
           <a:p>
@@ -3516,7 +3573,7 @@
               </a:defRPr>
             </a:pPr>
             <a:r>
-              <a:t>Fix 1 (for RC1): Root cause fix in module_list_remove() (core/module_list.c)</a:t>
+              <a:t>Fix 2 (for RC1): Root cause fix in module_list_remove() (core/module_list.c)</a:t>
             </a:r>
           </a:p>
           <a:p>
@@ -3531,7 +3588,34 @@
               </a:defRPr>
             </a:pPr>
             <a:r>
-              <a:t>Move module_area_delete() + vmvector removal before releasing write lock</a:t>
+              <a:t>Move module_area_delete() before releasing write lock — closes one race window</a:t>
+            </a:r>
+          </a:p>
+          <a:p>
+            <a:pPr>
+              <a:spcAft>
+                <a:spcPts val="300"/>
+              </a:spcAft>
+              <a:defRPr sz="1300">
+                <a:solidFill>
+                  <a:srgbClr val="2D2D2D"/>
+                </a:solidFill>
+              </a:defRPr>
+            </a:pPr>
+          </a:p>
+          <a:p>
+            <a:pPr>
+              <a:spcAft>
+                <a:spcPts val="300"/>
+              </a:spcAft>
+              <a:defRPr sz="1300">
+                <a:solidFill>
+                  <a:srgbClr val="2D2D2D"/>
+                </a:solidFill>
+              </a:defRPr>
+            </a:pPr>
+            <a:r>
+              <a:t>Fix 3 (for RC1): strhash_key_cmp safe_read guard (core/hashtable.c)</a:t>
             </a:r>
           </a:p>
           <a:p>
@@ -3546,11 +3630,11 @@
               </a:defRPr>
             </a:pPr>
             <a:r>
-              <a:t>Client callback only uses client_data (a copy), does not need original module_area_t</a:t>
-            </a:r>
-          </a:p>
-          <a:p>
-            <a:pPr lvl="1">
+              <a:t>Defense-in-depth: safe_read on hash table key pointers before strcmp</a:t>
+            </a:r>
+          </a:p>
+          <a:p>
+            <a:pPr>
               <a:spcAft>
                 <a:spcPts val="300"/>
               </a:spcAft>
@@ -3560,9 +3644,6 @@
                 </a:solidFill>
               </a:defRPr>
             </a:pPr>
-            <a:r>
-              <a:t>Eliminates the race window entirely — no thread can get a stale pointer</a:t>
-            </a:r>
           </a:p>
           <a:p>
             <a:pPr>
@@ -3575,62 +3656,8 @@
                 </a:solidFill>
               </a:defRPr>
             </a:pPr>
-          </a:p>
-          <a:p>
-            <a:pPr>
-              <a:spcAft>
-                <a:spcPts val="300"/>
-              </a:spcAft>
-              <a:defRPr sz="1300">
-                <a:solidFill>
-                  <a:srgbClr val="2D2D2D"/>
-                </a:solidFill>
-              </a:defRPr>
-            </a:pPr>
-            <a:r>
-              <a:t>Fix 2 (for RC1): strhash_key_cmp safe_read guard (core/hashtable.c)</a:t>
-            </a:r>
-          </a:p>
-          <a:p>
-            <a:pPr lvl="1">
-              <a:spcAft>
-                <a:spcPts val="300"/>
-              </a:spcAft>
-              <a:defRPr sz="1300">
-                <a:solidFill>
-                  <a:srgbClr val="2D2D2D"/>
-                </a:solidFill>
-              </a:defRPr>
-            </a:pPr>
-            <a:r>
-              <a:t>Defense-in-depth: safe_read check on hash table key pointers before strcmp</a:t>
-            </a:r>
-          </a:p>
-          <a:p>
-            <a:pPr>
-              <a:spcAft>
-                <a:spcPts val="300"/>
-              </a:spcAft>
-              <a:defRPr sz="1300">
-                <a:solidFill>
-                  <a:srgbClr val="2D2D2D"/>
-                </a:solidFill>
-              </a:defRPr>
-            </a:pPr>
-          </a:p>
-          <a:p>
-            <a:pPr>
-              <a:spcAft>
-                <a:spcPts val="300"/>
-              </a:spcAft>
-              <a:defRPr sz="1300">
-                <a:solidFill>
-                  <a:srgbClr val="2D2D2D"/>
-                </a:solidFill>
-              </a:defRPr>
-            </a:pPr>
-            <a:r>
-              <a:t>Fix 3 (for RC2): Per-job HOME override (scarab-infra, run_simpoint_trace.py)</a:t>
+            <a:r>
+              <a:t>Fix 4 (for RC2): Per-job HOME override (scarab-infra, run_simpoint_trace.py)</a:t>
             </a:r>
           </a:p>
           <a:p>
@@ -4946,7 +4973,7 @@
                         </a:defRPr>
                       </a:pPr>
                       <a:r>
-                        <a:t>Root cause fix in module_list_remove()</a:t>
+                        <a:t>d_r_strcmp safe_read guard (gated on dynamo_initialized)</a:t>
                       </a:r>
                     </a:p>
                     <a:p>
@@ -4958,7 +4985,7 @@
                         </a:defRPr>
                       </a:pPr>
                       <a:r>
-                        <a:t>+ strhash_key_cmp guard + HOME isolation</a:t>
+                        <a:t>+ module_list_remove fix + strhash_key_cmp guard + HOME isolation</a:t>
                       </a:r>
                     </a:p>
                   </a:txBody>
@@ -5283,7 +5310,7 @@
               </a:defRPr>
             </a:pPr>
             <a:r>
-              <a:t>2. Run Scarab cycle-accurate simulation on collected traces</a:t>
+              <a:t>2. Run Scarab simulation on collected traces</a:t>
             </a:r>
           </a:p>
           <a:p>
@@ -5298,7 +5325,7 @@
               </a:defRPr>
             </a:pPr>
             <a:r>
-              <a:t>Simulate each simpoint segment with detailed microarchitecture model</a:t>
+              <a:t>Simulate each simpoint segment with detailed microarchitecture model (add missing insts)</a:t>
             </a:r>
           </a:p>
           <a:p>
@@ -6261,7 +6288,7 @@
               </a:defRPr>
             </a:pPr>
             <a:r>
-              <a:t>Current CPU benchmarks (SPEC, GeekBench) don't capture agent execution patterns</a:t>
+              <a:t>Current CPU benchmarks (SPEC, Datacenter) don't capture agent execution patterns</a:t>
             </a:r>
           </a:p>
           <a:p>
@@ -6351,7 +6378,7 @@
               </a:defRPr>
             </a:pPr>
             <a:r>
-              <a:t>Method: perf stat (real HW) + SimPoint traces → Scarab cycle-accurate simulation</a:t>
+              <a:t>Method: perf stat (real HW) + SimPoint traces → Scarab simulation</a:t>
             </a:r>
           </a:p>
         </p:txBody>

</xml_diff>